<commit_message>
Correct architecture diagram to match real code flow + rebuild deck/video
- gen_diagram.py: accurate flow (Inputs -> Parser -> Supervisor -> Agents ->
  Fix-Router -> Output; modules reuse fix_router), honest 'Grounded knowledge'
  wording (not RAG), file-name annotations, solid/dashed legend
- gen_drawio.py: matching editable draw.io
- Deck slide 3 uses the corrected diagram; video rebuilt from real slides (1:59, same VO)

Co-authored-by: Copilot <223556219+Copilot@users.noreply.github.com>
</commit_message>
<xml_diff>
--- a/docs/ClosureCopilot.pptx
+++ b/docs/ClosureCopilot.pptx
@@ -4,20 +4,17 @@
   <p:sldMasterIdLst>
     <p:sldMasterId id="2147483648" r:id="rId1"/>
   </p:sldMasterIdLst>
-  <p:notesMasterIdLst>
-    <p:notesMasterId r:id="rId10"/>
-  </p:notesMasterIdLst>
   <p:sldIdLst>
-    <p:sldId id="256" r:id="rId2"/>
-    <p:sldId id="257" r:id="rId3"/>
-    <p:sldId id="258" r:id="rId4"/>
-    <p:sldId id="259" r:id="rId5"/>
-    <p:sldId id="260" r:id="rId6"/>
-    <p:sldId id="261" r:id="rId7"/>
-    <p:sldId id="262" r:id="rId8"/>
-    <p:sldId id="263" r:id="rId9"/>
+    <p:sldId id="256" r:id="rId7"/>
+    <p:sldId id="257" r:id="rId8"/>
+    <p:sldId id="258" r:id="rId9"/>
+    <p:sldId id="259" r:id="rId10"/>
+    <p:sldId id="260" r:id="rId11"/>
+    <p:sldId id="261" r:id="rId12"/>
+    <p:sldId id="262" r:id="rId13"/>
+    <p:sldId id="263" r:id="rId14"/>
   </p:sldIdLst>
-  <p:sldSz cx="12192000" cy="6858000"/>
+  <p:sldSz cx="12191695" cy="6858000" type="screen4x3"/>
   <p:notesSz cx="6858000" cy="9144000"/>
   <p:defaultTextStyle>
     <a:defPPr>
@@ -114,587 +111,7 @@
       </a:defRPr>
     </a:lvl9pPr>
   </p:defaultTextStyle>
-  <p:extLst>
-    <p:ext uri="{EFAFB233-063F-42B5-8137-9DF3F51BA10A}">
-      <p15:sldGuideLst xmlns:p15="http://schemas.microsoft.com/office/powerpoint/2012/main">
-        <p15:guide id="1" orient="horz" pos="2160">
-          <p15:clr>
-            <a:srgbClr val="A4A3A4"/>
-          </p15:clr>
-        </p15:guide>
-        <p15:guide id="2" pos="2880">
-          <p15:clr>
-            <a:srgbClr val="A4A3A4"/>
-          </p15:clr>
-        </p15:guide>
-      </p15:sldGuideLst>
-    </p:ext>
-  </p:extLst>
 </p:presentation>
-</file>
-
-<file path=ppt/revisionInfo.xml><?xml version="1.0" encoding="utf-8"?>
-<p1510:revInfo xmlns:a="http://schemas.openxmlformats.org/drawingml/2006/main" xmlns:r="http://schemas.openxmlformats.org/officeDocument/2006/relationships" xmlns:p1510="http://schemas.microsoft.com/office/powerpoint/2015/10/main">
-  <p1510:revLst>
-    <p1510:client id="{116BD6CD-ED46-48F3-A6FF-3F84F00B2497}" v="10" dt="2026-09-05T15:26:55.215"/>
-  </p1510:revLst>
-</p1510:revInfo>
-</file>
-
-<file path=ppt/changesInfos/changesInfo1.xml><?xml version="1.0" encoding="utf-8"?>
-<pc:chgInfo xmlns:a="http://schemas.openxmlformats.org/drawingml/2006/main" xmlns:r="http://schemas.openxmlformats.org/officeDocument/2006/relationships" xmlns:ac="http://schemas.microsoft.com/office/drawing/2013/main/command" xmlns:pc="http://schemas.microsoft.com/office/powerpoint/2013/main/command">
-  <pc:docChgLst>
-    <pc:chgData name="Mayuresh Piske" userId="aeb3d3e9-2c13-446e-8fc0-83f22db42824" providerId="ADAL" clId="{76688486-0801-4EB8-8479-3CA377FA07D4}"/>
-    <pc:docChg chg="undo custSel modSld">
-      <pc:chgData name="Mayuresh Piske" userId="aeb3d3e9-2c13-446e-8fc0-83f22db42824" providerId="ADAL" clId="{76688486-0801-4EB8-8479-3CA377FA07D4}" dt="2026-09-05T15:46:48.348" v="107" actId="1076"/>
-      <pc:docMkLst>
-        <pc:docMk/>
-      </pc:docMkLst>
-      <pc:sldChg chg="addSp delSp modSp mod">
-        <pc:chgData name="Mayuresh Piske" userId="aeb3d3e9-2c13-446e-8fc0-83f22db42824" providerId="ADAL" clId="{76688486-0801-4EB8-8479-3CA377FA07D4}" dt="2026-09-05T15:46:48.348" v="107" actId="1076"/>
-        <pc:sldMkLst>
-          <pc:docMk/>
-          <pc:sldMk cId="0" sldId="256"/>
-        </pc:sldMkLst>
-        <pc:spChg chg="mod">
-          <ac:chgData name="Mayuresh Piske" userId="aeb3d3e9-2c13-446e-8fc0-83f22db42824" providerId="ADAL" clId="{76688486-0801-4EB8-8479-3CA377FA07D4}" dt="2026-09-05T15:46:43.561" v="106" actId="1076"/>
-          <ac:spMkLst>
-            <pc:docMk/>
-            <pc:sldMk cId="0" sldId="256"/>
-            <ac:spMk id="3" creationId="{00000000-0000-0000-0000-000000000000}"/>
-          </ac:spMkLst>
-        </pc:spChg>
-        <pc:spChg chg="add mod">
-          <ac:chgData name="Mayuresh Piske" userId="aeb3d3e9-2c13-446e-8fc0-83f22db42824" providerId="ADAL" clId="{76688486-0801-4EB8-8479-3CA377FA07D4}" dt="2026-09-05T15:19:12.708" v="4" actId="571"/>
-          <ac:spMkLst>
-            <pc:docMk/>
-            <pc:sldMk cId="0" sldId="256"/>
-            <ac:spMk id="8" creationId="{7160E950-381A-9493-E97E-A5C157321C4D}"/>
-          </ac:spMkLst>
-        </pc:spChg>
-        <pc:spChg chg="add mod">
-          <ac:chgData name="Mayuresh Piske" userId="aeb3d3e9-2c13-446e-8fc0-83f22db42824" providerId="ADAL" clId="{76688486-0801-4EB8-8479-3CA377FA07D4}" dt="2026-09-05T15:19:21.693" v="7" actId="571"/>
-          <ac:spMkLst>
-            <pc:docMk/>
-            <pc:sldMk cId="0" sldId="256"/>
-            <ac:spMk id="9" creationId="{F9C852E8-C7BC-811C-B1EF-9314B6D6C9AA}"/>
-          </ac:spMkLst>
-        </pc:spChg>
-        <pc:spChg chg="add mod">
-          <ac:chgData name="Mayuresh Piske" userId="aeb3d3e9-2c13-446e-8fc0-83f22db42824" providerId="ADAL" clId="{76688486-0801-4EB8-8479-3CA377FA07D4}" dt="2026-09-05T15:46:48.348" v="107" actId="1076"/>
-          <ac:spMkLst>
-            <pc:docMk/>
-            <pc:sldMk cId="0" sldId="256"/>
-            <ac:spMk id="11" creationId="{B25F93AE-AE4B-0369-7B8A-DF9D4A6D992F}"/>
-          </ac:spMkLst>
-        </pc:spChg>
-        <pc:spChg chg="del mod">
-          <ac:chgData name="Mayuresh Piske" userId="aeb3d3e9-2c13-446e-8fc0-83f22db42824" providerId="ADAL" clId="{76688486-0801-4EB8-8479-3CA377FA07D4}" dt="2026-09-05T15:35:46.493" v="95" actId="478"/>
-          <ac:spMkLst>
-            <pc:docMk/>
-            <pc:sldMk cId="0" sldId="256"/>
-            <ac:spMk id="12" creationId="{56D8762E-D1DB-7AEA-C625-87FE1BCBAC7A}"/>
-          </ac:spMkLst>
-        </pc:spChg>
-      </pc:sldChg>
-      <pc:sldChg chg="delSp modSp mod">
-        <pc:chgData name="Mayuresh Piske" userId="aeb3d3e9-2c13-446e-8fc0-83f22db42824" providerId="ADAL" clId="{76688486-0801-4EB8-8479-3CA377FA07D4}" dt="2026-09-05T15:28:49.532" v="76" actId="1076"/>
-        <pc:sldMkLst>
-          <pc:docMk/>
-          <pc:sldMk cId="0" sldId="257"/>
-        </pc:sldMkLst>
-        <pc:spChg chg="del mod">
-          <ac:chgData name="Mayuresh Piske" userId="aeb3d3e9-2c13-446e-8fc0-83f22db42824" providerId="ADAL" clId="{76688486-0801-4EB8-8479-3CA377FA07D4}" dt="2026-09-05T15:26:23.488" v="36" actId="478"/>
-          <ac:spMkLst>
-            <pc:docMk/>
-            <pc:sldMk cId="0" sldId="257"/>
-            <ac:spMk id="2" creationId="{00000000-0000-0000-0000-000000000000}"/>
-          </ac:spMkLst>
-        </pc:spChg>
-        <pc:spChg chg="mod">
-          <ac:chgData name="Mayuresh Piske" userId="aeb3d3e9-2c13-446e-8fc0-83f22db42824" providerId="ADAL" clId="{76688486-0801-4EB8-8479-3CA377FA07D4}" dt="2026-09-05T15:28:49.532" v="76" actId="1076"/>
-          <ac:spMkLst>
-            <pc:docMk/>
-            <pc:sldMk cId="0" sldId="257"/>
-            <ac:spMk id="13" creationId="{2CD06639-3C8E-33C0-FE69-B7ADA560992A}"/>
-          </ac:spMkLst>
-        </pc:spChg>
-      </pc:sldChg>
-      <pc:sldChg chg="modSp mod">
-        <pc:chgData name="Mayuresh Piske" userId="aeb3d3e9-2c13-446e-8fc0-83f22db42824" providerId="ADAL" clId="{76688486-0801-4EB8-8479-3CA377FA07D4}" dt="2026-09-05T15:36:38.970" v="104" actId="20577"/>
-        <pc:sldMkLst>
-          <pc:docMk/>
-          <pc:sldMk cId="0" sldId="258"/>
-        </pc:sldMkLst>
-        <pc:spChg chg="mod">
-          <ac:chgData name="Mayuresh Piske" userId="aeb3d3e9-2c13-446e-8fc0-83f22db42824" providerId="ADAL" clId="{76688486-0801-4EB8-8479-3CA377FA07D4}" dt="2026-09-05T15:36:38.970" v="104" actId="20577"/>
-          <ac:spMkLst>
-            <pc:docMk/>
-            <pc:sldMk cId="0" sldId="258"/>
-            <ac:spMk id="4" creationId="{00000000-0000-0000-0000-000000000000}"/>
-          </ac:spMkLst>
-        </pc:spChg>
-        <pc:spChg chg="mod">
-          <ac:chgData name="Mayuresh Piske" userId="aeb3d3e9-2c13-446e-8fc0-83f22db42824" providerId="ADAL" clId="{76688486-0801-4EB8-8479-3CA377FA07D4}" dt="2026-09-05T15:36:10.470" v="97" actId="14100"/>
-          <ac:spMkLst>
-            <pc:docMk/>
-            <pc:sldMk cId="0" sldId="258"/>
-            <ac:spMk id="7" creationId="{70C64B5F-0A6D-53D4-7F8E-684E630ACE64}"/>
-          </ac:spMkLst>
-        </pc:spChg>
-        <pc:picChg chg="mod">
-          <ac:chgData name="Mayuresh Piske" userId="aeb3d3e9-2c13-446e-8fc0-83f22db42824" providerId="ADAL" clId="{76688486-0801-4EB8-8479-3CA377FA07D4}" dt="2026-09-05T15:36:26.293" v="98" actId="14100"/>
-          <ac:picMkLst>
-            <pc:docMk/>
-            <pc:sldMk cId="0" sldId="258"/>
-            <ac:picMk id="5" creationId="{00000000-0000-0000-0000-000000000000}"/>
-          </ac:picMkLst>
-        </pc:picChg>
-      </pc:sldChg>
-      <pc:sldChg chg="modSp mod">
-        <pc:chgData name="Mayuresh Piske" userId="aeb3d3e9-2c13-446e-8fc0-83f22db42824" providerId="ADAL" clId="{76688486-0801-4EB8-8479-3CA377FA07D4}" dt="2026-09-05T15:27:57.266" v="54" actId="1076"/>
-        <pc:sldMkLst>
-          <pc:docMk/>
-          <pc:sldMk cId="0" sldId="259"/>
-        </pc:sldMkLst>
-        <pc:spChg chg="mod">
-          <ac:chgData name="Mayuresh Piske" userId="aeb3d3e9-2c13-446e-8fc0-83f22db42824" providerId="ADAL" clId="{76688486-0801-4EB8-8479-3CA377FA07D4}" dt="2026-09-05T15:27:48.018" v="52" actId="1076"/>
-          <ac:spMkLst>
-            <pc:docMk/>
-            <pc:sldMk cId="0" sldId="259"/>
-            <ac:spMk id="2" creationId="{00000000-0000-0000-0000-000000000000}"/>
-          </ac:spMkLst>
-        </pc:spChg>
-        <pc:spChg chg="mod">
-          <ac:chgData name="Mayuresh Piske" userId="aeb3d3e9-2c13-446e-8fc0-83f22db42824" providerId="ADAL" clId="{76688486-0801-4EB8-8479-3CA377FA07D4}" dt="2026-09-05T15:27:57.266" v="54" actId="1076"/>
-          <ac:spMkLst>
-            <pc:docMk/>
-            <pc:sldMk cId="0" sldId="259"/>
-            <ac:spMk id="11" creationId="{CDCA28F5-24ED-C6C5-22BD-9A93D513A93A}"/>
-          </ac:spMkLst>
-        </pc:spChg>
-      </pc:sldChg>
-      <pc:sldChg chg="modSp mod">
-        <pc:chgData name="Mayuresh Piske" userId="aeb3d3e9-2c13-446e-8fc0-83f22db42824" providerId="ADAL" clId="{76688486-0801-4EB8-8479-3CA377FA07D4}" dt="2026-09-05T15:27:41.067" v="49" actId="1076"/>
-        <pc:sldMkLst>
-          <pc:docMk/>
-          <pc:sldMk cId="0" sldId="260"/>
-        </pc:sldMkLst>
-        <pc:spChg chg="mod">
-          <ac:chgData name="Mayuresh Piske" userId="aeb3d3e9-2c13-446e-8fc0-83f22db42824" providerId="ADAL" clId="{76688486-0801-4EB8-8479-3CA377FA07D4}" dt="2026-09-05T15:27:41.067" v="49" actId="1076"/>
-          <ac:spMkLst>
-            <pc:docMk/>
-            <pc:sldMk cId="0" sldId="260"/>
-            <ac:spMk id="25" creationId="{7E55F50A-2D07-CDDF-D02C-81095889BAF9}"/>
-          </ac:spMkLst>
-        </pc:spChg>
-      </pc:sldChg>
-      <pc:sldChg chg="modSp mod">
-        <pc:chgData name="Mayuresh Piske" userId="aeb3d3e9-2c13-446e-8fc0-83f22db42824" providerId="ADAL" clId="{76688486-0801-4EB8-8479-3CA377FA07D4}" dt="2026-09-05T15:27:32.513" v="47" actId="1076"/>
-        <pc:sldMkLst>
-          <pc:docMk/>
-          <pc:sldMk cId="0" sldId="261"/>
-        </pc:sldMkLst>
-        <pc:spChg chg="mod">
-          <ac:chgData name="Mayuresh Piske" userId="aeb3d3e9-2c13-446e-8fc0-83f22db42824" providerId="ADAL" clId="{76688486-0801-4EB8-8479-3CA377FA07D4}" dt="2026-09-05T15:27:32.513" v="47" actId="1076"/>
-          <ac:spMkLst>
-            <pc:docMk/>
-            <pc:sldMk cId="0" sldId="261"/>
-            <ac:spMk id="9" creationId="{FB081541-3697-02EB-CA09-947B1D5C7B05}"/>
-          </ac:spMkLst>
-        </pc:spChg>
-      </pc:sldChg>
-      <pc:sldChg chg="modSp mod">
-        <pc:chgData name="Mayuresh Piske" userId="aeb3d3e9-2c13-446e-8fc0-83f22db42824" providerId="ADAL" clId="{76688486-0801-4EB8-8479-3CA377FA07D4}" dt="2026-09-05T15:27:24.766" v="45" actId="1076"/>
-        <pc:sldMkLst>
-          <pc:docMk/>
-          <pc:sldMk cId="0" sldId="262"/>
-        </pc:sldMkLst>
-        <pc:spChg chg="mod">
-          <ac:chgData name="Mayuresh Piske" userId="aeb3d3e9-2c13-446e-8fc0-83f22db42824" providerId="ADAL" clId="{76688486-0801-4EB8-8479-3CA377FA07D4}" dt="2026-09-05T15:27:24.766" v="45" actId="1076"/>
-          <ac:spMkLst>
-            <pc:docMk/>
-            <pc:sldMk cId="0" sldId="262"/>
-            <ac:spMk id="9" creationId="{3F30E14D-839F-E276-DF2D-B2EF76D28596}"/>
-          </ac:spMkLst>
-        </pc:spChg>
-      </pc:sldChg>
-      <pc:sldChg chg="modSp mod">
-        <pc:chgData name="Mayuresh Piske" userId="aeb3d3e9-2c13-446e-8fc0-83f22db42824" providerId="ADAL" clId="{76688486-0801-4EB8-8479-3CA377FA07D4}" dt="2026-09-05T15:27:16.846" v="43" actId="1076"/>
-        <pc:sldMkLst>
-          <pc:docMk/>
-          <pc:sldMk cId="0" sldId="263"/>
-        </pc:sldMkLst>
-        <pc:spChg chg="mod">
-          <ac:chgData name="Mayuresh Piske" userId="aeb3d3e9-2c13-446e-8fc0-83f22db42824" providerId="ADAL" clId="{76688486-0801-4EB8-8479-3CA377FA07D4}" dt="2026-09-05T15:27:12.699" v="42" actId="1076"/>
-          <ac:spMkLst>
-            <pc:docMk/>
-            <pc:sldMk cId="0" sldId="263"/>
-            <ac:spMk id="2" creationId="{00000000-0000-0000-0000-000000000000}"/>
-          </ac:spMkLst>
-        </pc:spChg>
-        <pc:spChg chg="mod">
-          <ac:chgData name="Mayuresh Piske" userId="aeb3d3e9-2c13-446e-8fc0-83f22db42824" providerId="ADAL" clId="{76688486-0801-4EB8-8479-3CA377FA07D4}" dt="2026-09-05T15:27:16.846" v="43" actId="1076"/>
-          <ac:spMkLst>
-            <pc:docMk/>
-            <pc:sldMk cId="0" sldId="263"/>
-            <ac:spMk id="6" creationId="{C4C2C17A-6560-086A-57BE-9E6D36D66ACA}"/>
-          </ac:spMkLst>
-        </pc:spChg>
-      </pc:sldChg>
-    </pc:docChg>
-  </pc:docChgLst>
-</pc:chgInfo>
-</file>
-
-<file path=ppt/notesMasters/notesMaster1.xml><?xml version="1.0" encoding="utf-8"?>
-<p:notesMaster xmlns:a="http://schemas.openxmlformats.org/drawingml/2006/main" xmlns:r="http://schemas.openxmlformats.org/officeDocument/2006/relationships" xmlns:p="http://schemas.openxmlformats.org/presentationml/2006/main">
-  <p:cSld>
-    <p:bg>
-      <p:bgRef idx="1001">
-        <a:schemeClr val="bg1"/>
-      </p:bgRef>
-    </p:bg>
-    <p:spTree>
-      <p:nvGrpSpPr>
-        <p:cNvPr id="1" name=""/>
-        <p:cNvGrpSpPr/>
-        <p:nvPr/>
-      </p:nvGrpSpPr>
-      <p:grpSpPr>
-        <a:xfrm>
-          <a:off x="0" y="0"/>
-          <a:ext cx="0" cy="0"/>
-          <a:chOff x="0" y="0"/>
-          <a:chExt cx="0" cy="0"/>
-        </a:xfrm>
-      </p:grpSpPr>
-      <p:sp>
-        <p:nvSpPr>
-          <p:cNvPr id="2" name="Header Placeholder 1"/>
-          <p:cNvSpPr>
-            <a:spLocks noGrp="1"/>
-          </p:cNvSpPr>
-          <p:nvPr>
-            <p:ph type="hdr" sz="quarter"/>
-          </p:nvPr>
-        </p:nvSpPr>
-        <p:spPr>
-          <a:xfrm>
-            <a:off x="0" y="0"/>
-            <a:ext cx="2971800" cy="458788"/>
-          </a:xfrm>
-          <a:prstGeom prst="rect">
-            <a:avLst/>
-          </a:prstGeom>
-        </p:spPr>
-        <p:txBody>
-          <a:bodyPr vert="horz" lIns="91440" tIns="45720" rIns="91440" bIns="45720" rtlCol="0"/>
-          <a:lstStyle>
-            <a:lvl1pPr algn="l">
-              <a:defRPr sz="1200"/>
-            </a:lvl1pPr>
-          </a:lstStyle>
-          <a:p>
-            <a:endParaRPr lang="en-IN"/>
-          </a:p>
-        </p:txBody>
-      </p:sp>
-      <p:sp>
-        <p:nvSpPr>
-          <p:cNvPr id="3" name="Date Placeholder 2"/>
-          <p:cNvSpPr>
-            <a:spLocks noGrp="1"/>
-          </p:cNvSpPr>
-          <p:nvPr>
-            <p:ph type="dt" idx="1"/>
-          </p:nvPr>
-        </p:nvSpPr>
-        <p:spPr>
-          <a:xfrm>
-            <a:off x="3884613" y="0"/>
-            <a:ext cx="2971800" cy="458788"/>
-          </a:xfrm>
-          <a:prstGeom prst="rect">
-            <a:avLst/>
-          </a:prstGeom>
-        </p:spPr>
-        <p:txBody>
-          <a:bodyPr vert="horz" lIns="91440" tIns="45720" rIns="91440" bIns="45720" rtlCol="0"/>
-          <a:lstStyle>
-            <a:lvl1pPr algn="r">
-              <a:defRPr sz="1200"/>
-            </a:lvl1pPr>
-          </a:lstStyle>
-          <a:p>
-            <a:fld id="{08CC7E1A-73E7-4392-AC6F-F56983B15E02}" type="datetimeFigureOut">
-              <a:rPr lang="en-IN" smtClean="0"/>
-              <a:t>05-09-2026</a:t>
-            </a:fld>
-            <a:endParaRPr lang="en-IN"/>
-          </a:p>
-        </p:txBody>
-      </p:sp>
-      <p:sp>
-        <p:nvSpPr>
-          <p:cNvPr id="4" name="Slide Image Placeholder 3"/>
-          <p:cNvSpPr>
-            <a:spLocks noGrp="1" noRot="1" noChangeAspect="1"/>
-          </p:cNvSpPr>
-          <p:nvPr>
-            <p:ph type="sldImg" idx="2"/>
-          </p:nvPr>
-        </p:nvSpPr>
-        <p:spPr>
-          <a:xfrm>
-            <a:off x="685800" y="1143000"/>
-            <a:ext cx="5486400" cy="3086100"/>
-          </a:xfrm>
-          <a:prstGeom prst="rect">
-            <a:avLst/>
-          </a:prstGeom>
-          <a:noFill/>
-          <a:ln w="12700">
-            <a:solidFill>
-              <a:prstClr val="black"/>
-            </a:solidFill>
-          </a:ln>
-        </p:spPr>
-        <p:txBody>
-          <a:bodyPr vert="horz" lIns="91440" tIns="45720" rIns="91440" bIns="45720" rtlCol="0" anchor="ctr"/>
-          <a:lstStyle/>
-          <a:p>
-            <a:endParaRPr lang="en-IN"/>
-          </a:p>
-        </p:txBody>
-      </p:sp>
-      <p:sp>
-        <p:nvSpPr>
-          <p:cNvPr id="5" name="Notes Placeholder 4"/>
-          <p:cNvSpPr>
-            <a:spLocks noGrp="1"/>
-          </p:cNvSpPr>
-          <p:nvPr>
-            <p:ph type="body" sz="quarter" idx="3"/>
-          </p:nvPr>
-        </p:nvSpPr>
-        <p:spPr>
-          <a:xfrm>
-            <a:off x="685800" y="4400550"/>
-            <a:ext cx="5486400" cy="3600450"/>
-          </a:xfrm>
-          <a:prstGeom prst="rect">
-            <a:avLst/>
-          </a:prstGeom>
-        </p:spPr>
-        <p:txBody>
-          <a:bodyPr vert="horz" lIns="91440" tIns="45720" rIns="91440" bIns="45720" rtlCol="0"/>
-          <a:lstStyle/>
-          <a:p>
-            <a:pPr lvl="0"/>
-            <a:r>
-              <a:rPr lang="en-GB"/>
-              <a:t>Click to edit Master text styles</a:t>
-            </a:r>
-          </a:p>
-          <a:p>
-            <a:pPr lvl="1"/>
-            <a:r>
-              <a:rPr lang="en-GB"/>
-              <a:t>Second level</a:t>
-            </a:r>
-          </a:p>
-          <a:p>
-            <a:pPr lvl="2"/>
-            <a:r>
-              <a:rPr lang="en-GB"/>
-              <a:t>Third level</a:t>
-            </a:r>
-          </a:p>
-          <a:p>
-            <a:pPr lvl="3"/>
-            <a:r>
-              <a:rPr lang="en-GB"/>
-              <a:t>Fourth level</a:t>
-            </a:r>
-          </a:p>
-          <a:p>
-            <a:pPr lvl="4"/>
-            <a:r>
-              <a:rPr lang="en-GB"/>
-              <a:t>Fifth level</a:t>
-            </a:r>
-            <a:endParaRPr lang="en-IN"/>
-          </a:p>
-        </p:txBody>
-      </p:sp>
-      <p:sp>
-        <p:nvSpPr>
-          <p:cNvPr id="6" name="Footer Placeholder 5"/>
-          <p:cNvSpPr>
-            <a:spLocks noGrp="1"/>
-          </p:cNvSpPr>
-          <p:nvPr>
-            <p:ph type="ftr" sz="quarter" idx="4"/>
-          </p:nvPr>
-        </p:nvSpPr>
-        <p:spPr>
-          <a:xfrm>
-            <a:off x="0" y="8685213"/>
-            <a:ext cx="2971800" cy="458787"/>
-          </a:xfrm>
-          <a:prstGeom prst="rect">
-            <a:avLst/>
-          </a:prstGeom>
-        </p:spPr>
-        <p:txBody>
-          <a:bodyPr vert="horz" lIns="91440" tIns="45720" rIns="91440" bIns="45720" rtlCol="0" anchor="b"/>
-          <a:lstStyle>
-            <a:lvl1pPr algn="l">
-              <a:defRPr sz="1200"/>
-            </a:lvl1pPr>
-          </a:lstStyle>
-          <a:p>
-            <a:endParaRPr lang="en-IN"/>
-          </a:p>
-        </p:txBody>
-      </p:sp>
-      <p:sp>
-        <p:nvSpPr>
-          <p:cNvPr id="7" name="Slide Number Placeholder 6"/>
-          <p:cNvSpPr>
-            <a:spLocks noGrp="1"/>
-          </p:cNvSpPr>
-          <p:nvPr>
-            <p:ph type="sldNum" sz="quarter" idx="5"/>
-          </p:nvPr>
-        </p:nvSpPr>
-        <p:spPr>
-          <a:xfrm>
-            <a:off x="3884613" y="8685213"/>
-            <a:ext cx="2971800" cy="458787"/>
-          </a:xfrm>
-          <a:prstGeom prst="rect">
-            <a:avLst/>
-          </a:prstGeom>
-        </p:spPr>
-        <p:txBody>
-          <a:bodyPr vert="horz" lIns="91440" tIns="45720" rIns="91440" bIns="45720" rtlCol="0" anchor="b"/>
-          <a:lstStyle>
-            <a:lvl1pPr algn="r">
-              <a:defRPr sz="1200"/>
-            </a:lvl1pPr>
-          </a:lstStyle>
-          <a:p>
-            <a:fld id="{515C6A6E-78E3-4131-AA1F-BE872D646191}" type="slidenum">
-              <a:rPr lang="en-IN" smtClean="0"/>
-              <a:t>‹#›</a:t>
-            </a:fld>
-            <a:endParaRPr lang="en-IN"/>
-          </a:p>
-        </p:txBody>
-      </p:sp>
-    </p:spTree>
-    <p:extLst>
-      <p:ext uri="{BB962C8B-B14F-4D97-AF65-F5344CB8AC3E}">
-        <p14:creationId xmlns:p14="http://schemas.microsoft.com/office/powerpoint/2010/main" val="1665279300"/>
-      </p:ext>
-    </p:extLst>
-  </p:cSld>
-  <p:clrMap bg1="lt1" tx1="dk1" bg2="lt2" tx2="dk2" accent1="accent1" accent2="accent2" accent3="accent3" accent4="accent4" accent5="accent5" accent6="accent6" hlink="hlink" folHlink="folHlink"/>
-  <p:notesStyle>
-    <a:lvl1pPr marL="0" algn="l" defTabSz="914400" rtl="0" eaLnBrk="1" latinLnBrk="0" hangingPunct="1">
-      <a:defRPr sz="1200" kern="1200">
-        <a:solidFill>
-          <a:schemeClr val="tx1"/>
-        </a:solidFill>
-        <a:latin typeface="+mn-lt"/>
-        <a:ea typeface="+mn-ea"/>
-        <a:cs typeface="+mn-cs"/>
-      </a:defRPr>
-    </a:lvl1pPr>
-    <a:lvl2pPr marL="457200" algn="l" defTabSz="914400" rtl="0" eaLnBrk="1" latinLnBrk="0" hangingPunct="1">
-      <a:defRPr sz="1200" kern="1200">
-        <a:solidFill>
-          <a:schemeClr val="tx1"/>
-        </a:solidFill>
-        <a:latin typeface="+mn-lt"/>
-        <a:ea typeface="+mn-ea"/>
-        <a:cs typeface="+mn-cs"/>
-      </a:defRPr>
-    </a:lvl2pPr>
-    <a:lvl3pPr marL="914400" algn="l" defTabSz="914400" rtl="0" eaLnBrk="1" latinLnBrk="0" hangingPunct="1">
-      <a:defRPr sz="1200" kern="1200">
-        <a:solidFill>
-          <a:schemeClr val="tx1"/>
-        </a:solidFill>
-        <a:latin typeface="+mn-lt"/>
-        <a:ea typeface="+mn-ea"/>
-        <a:cs typeface="+mn-cs"/>
-      </a:defRPr>
-    </a:lvl3pPr>
-    <a:lvl4pPr marL="1371600" algn="l" defTabSz="914400" rtl="0" eaLnBrk="1" latinLnBrk="0" hangingPunct="1">
-      <a:defRPr sz="1200" kern="1200">
-        <a:solidFill>
-          <a:schemeClr val="tx1"/>
-        </a:solidFill>
-        <a:latin typeface="+mn-lt"/>
-        <a:ea typeface="+mn-ea"/>
-        <a:cs typeface="+mn-cs"/>
-      </a:defRPr>
-    </a:lvl4pPr>
-    <a:lvl5pPr marL="1828800" algn="l" defTabSz="914400" rtl="0" eaLnBrk="1" latinLnBrk="0" hangingPunct="1">
-      <a:defRPr sz="1200" kern="1200">
-        <a:solidFill>
-          <a:schemeClr val="tx1"/>
-        </a:solidFill>
-        <a:latin typeface="+mn-lt"/>
-        <a:ea typeface="+mn-ea"/>
-        <a:cs typeface="+mn-cs"/>
-      </a:defRPr>
-    </a:lvl5pPr>
-    <a:lvl6pPr marL="2286000" algn="l" defTabSz="914400" rtl="0" eaLnBrk="1" latinLnBrk="0" hangingPunct="1">
-      <a:defRPr sz="1200" kern="1200">
-        <a:solidFill>
-          <a:schemeClr val="tx1"/>
-        </a:solidFill>
-        <a:latin typeface="+mn-lt"/>
-        <a:ea typeface="+mn-ea"/>
-        <a:cs typeface="+mn-cs"/>
-      </a:defRPr>
-    </a:lvl6pPr>
-    <a:lvl7pPr marL="2743200" algn="l" defTabSz="914400" rtl="0" eaLnBrk="1" latinLnBrk="0" hangingPunct="1">
-      <a:defRPr sz="1200" kern="1200">
-        <a:solidFill>
-          <a:schemeClr val="tx1"/>
-        </a:solidFill>
-        <a:latin typeface="+mn-lt"/>
-        <a:ea typeface="+mn-ea"/>
-        <a:cs typeface="+mn-cs"/>
-      </a:defRPr>
-    </a:lvl7pPr>
-    <a:lvl8pPr marL="3200400" algn="l" defTabSz="914400" rtl="0" eaLnBrk="1" latinLnBrk="0" hangingPunct="1">
-      <a:defRPr sz="1200" kern="1200">
-        <a:solidFill>
-          <a:schemeClr val="tx1"/>
-        </a:solidFill>
-        <a:latin typeface="+mn-lt"/>
-        <a:ea typeface="+mn-ea"/>
-        <a:cs typeface="+mn-cs"/>
-      </a:defRPr>
-    </a:lvl8pPr>
-    <a:lvl9pPr marL="3657600" algn="l" defTabSz="914400" rtl="0" eaLnBrk="1" latinLnBrk="0" hangingPunct="1">
-      <a:defRPr sz="1200" kern="1200">
-        <a:solidFill>
-          <a:schemeClr val="tx1"/>
-        </a:solidFill>
-        <a:latin typeface="+mn-lt"/>
-        <a:ea typeface="+mn-ea"/>
-        <a:cs typeface="+mn-cs"/>
-      </a:defRPr>
-    </a:lvl9pPr>
-  </p:notesStyle>
-</p:notesMaster>
 </file>
 
 <file path=ppt/slideLayouts/slideLayout1.xml><?xml version="1.0" encoding="utf-8"?>
@@ -735,9 +152,10 @@
           <a:lstStyle/>
           <a:p>
             <a:r>
-              <a:rPr lang="en-US"/>
+              <a:rPr lang="en-US" smtClean="0"/>
               <a:t>Click to edit Master title style</a:t>
             </a:r>
+            <a:endParaRPr lang="en-US"/>
           </a:p>
         </p:txBody>
       </p:sp>
@@ -853,9 +271,10 @@
           </a:lstStyle>
           <a:p>
             <a:r>
-              <a:rPr lang="en-US"/>
+              <a:rPr lang="en-US" smtClean="0"/>
               <a:t>Click to edit Master subtitle style</a:t>
             </a:r>
+            <a:endParaRPr lang="en-US"/>
           </a:p>
         </p:txBody>
       </p:sp>
@@ -874,9 +293,9 @@
           <a:bodyPr/>
           <a:lstStyle/>
           <a:p>
-            <a:fld id="{C31A860E-A5C9-4BB3-9D24-03426CEDA1FE}" type="datetime1">
-              <a:rPr lang="en-US" smtClean="0"/>
-              <a:t>9/5/2026</a:t>
+            <a:fld id="{5BCAD085-E8A6-8845-BD4E-CB4CCA059FC4}" type="datetimeFigureOut">
+              <a:rPr lang="en-US" smtClean="0"/>
+              <a:t>1/27/13</a:t>
             </a:fld>
             <a:endParaRPr lang="en-US"/>
           </a:p>
@@ -897,10 +316,7 @@
           <a:bodyPr/>
           <a:lstStyle/>
           <a:p>
-            <a:r>
-              <a:rPr lang="en-US"/>
-              <a:t>ClosureCopilot · Mayuresh Piske · © 2026 Microsoft</a:t>
-            </a:r>
+            <a:endParaRPr lang="en-US"/>
           </a:p>
         </p:txBody>
       </p:sp>
@@ -973,9 +389,10 @@
           <a:lstStyle/>
           <a:p>
             <a:r>
-              <a:rPr lang="en-US"/>
+              <a:rPr lang="en-US" smtClean="0"/>
               <a:t>Click to edit Master title style</a:t>
             </a:r>
+            <a:endParaRPr lang="en-US"/>
           </a:p>
         </p:txBody>
       </p:sp>
@@ -996,37 +413,38 @@
           <a:p>
             <a:pPr lvl="0"/>
             <a:r>
-              <a:rPr lang="en-US"/>
+              <a:rPr lang="en-US" smtClean="0"/>
               <a:t>Click to edit Master text styles</a:t>
             </a:r>
           </a:p>
           <a:p>
             <a:pPr lvl="1"/>
             <a:r>
-              <a:rPr lang="en-US"/>
+              <a:rPr lang="en-US" smtClean="0"/>
               <a:t>Second level</a:t>
             </a:r>
           </a:p>
           <a:p>
             <a:pPr lvl="2"/>
             <a:r>
-              <a:rPr lang="en-US"/>
+              <a:rPr lang="en-US" smtClean="0"/>
               <a:t>Third level</a:t>
             </a:r>
           </a:p>
           <a:p>
             <a:pPr lvl="3"/>
             <a:r>
-              <a:rPr lang="en-US"/>
+              <a:rPr lang="en-US" smtClean="0"/>
               <a:t>Fourth level</a:t>
             </a:r>
           </a:p>
           <a:p>
             <a:pPr lvl="4"/>
             <a:r>
-              <a:rPr lang="en-US"/>
+              <a:rPr lang="en-US" smtClean="0"/>
               <a:t>Fifth level</a:t>
             </a:r>
+            <a:endParaRPr lang="en-US"/>
           </a:p>
         </p:txBody>
       </p:sp>
@@ -1045,9 +463,9 @@
           <a:bodyPr/>
           <a:lstStyle/>
           <a:p>
-            <a:fld id="{E113E97C-F88E-4447-9191-634C0FE55DE7}" type="datetime1">
-              <a:rPr lang="en-US" smtClean="0"/>
-              <a:t>9/5/2026</a:t>
+            <a:fld id="{5BCAD085-E8A6-8845-BD4E-CB4CCA059FC4}" type="datetimeFigureOut">
+              <a:rPr lang="en-US" smtClean="0"/>
+              <a:t>1/27/13</a:t>
             </a:fld>
             <a:endParaRPr lang="en-US"/>
           </a:p>
@@ -1068,10 +486,7 @@
           <a:bodyPr/>
           <a:lstStyle/>
           <a:p>
-            <a:r>
-              <a:rPr lang="en-US"/>
-              <a:t>ClosureCopilot · Mayuresh Piske · © 2026 Microsoft</a:t>
-            </a:r>
+            <a:endParaRPr lang="en-US"/>
           </a:p>
         </p:txBody>
       </p:sp>
@@ -1149,9 +564,10 @@
           <a:lstStyle/>
           <a:p>
             <a:r>
-              <a:rPr lang="en-US"/>
+              <a:rPr lang="en-US" smtClean="0"/>
               <a:t>Click to edit Master title style</a:t>
             </a:r>
+            <a:endParaRPr lang="en-US"/>
           </a:p>
         </p:txBody>
       </p:sp>
@@ -1177,37 +593,38 @@
           <a:p>
             <a:pPr lvl="0"/>
             <a:r>
-              <a:rPr lang="en-US"/>
+              <a:rPr lang="en-US" smtClean="0"/>
               <a:t>Click to edit Master text styles</a:t>
             </a:r>
           </a:p>
           <a:p>
             <a:pPr lvl="1"/>
             <a:r>
-              <a:rPr lang="en-US"/>
+              <a:rPr lang="en-US" smtClean="0"/>
               <a:t>Second level</a:t>
             </a:r>
           </a:p>
           <a:p>
             <a:pPr lvl="2"/>
             <a:r>
-              <a:rPr lang="en-US"/>
+              <a:rPr lang="en-US" smtClean="0"/>
               <a:t>Third level</a:t>
             </a:r>
           </a:p>
           <a:p>
             <a:pPr lvl="3"/>
             <a:r>
-              <a:rPr lang="en-US"/>
+              <a:rPr lang="en-US" smtClean="0"/>
               <a:t>Fourth level</a:t>
             </a:r>
           </a:p>
           <a:p>
             <a:pPr lvl="4"/>
             <a:r>
-              <a:rPr lang="en-US"/>
+              <a:rPr lang="en-US" smtClean="0"/>
               <a:t>Fifth level</a:t>
             </a:r>
+            <a:endParaRPr lang="en-US"/>
           </a:p>
         </p:txBody>
       </p:sp>
@@ -1226,9 +643,9 @@
           <a:bodyPr/>
           <a:lstStyle/>
           <a:p>
-            <a:fld id="{7B1E1322-D978-49E8-9CD9-57D38ACFCED6}" type="datetime1">
-              <a:rPr lang="en-US" smtClean="0"/>
-              <a:t>9/5/2026</a:t>
+            <a:fld id="{5BCAD085-E8A6-8845-BD4E-CB4CCA059FC4}" type="datetimeFigureOut">
+              <a:rPr lang="en-US" smtClean="0"/>
+              <a:t>1/27/13</a:t>
             </a:fld>
             <a:endParaRPr lang="en-US"/>
           </a:p>
@@ -1249,10 +666,7 @@
           <a:bodyPr/>
           <a:lstStyle/>
           <a:p>
-            <a:r>
-              <a:rPr lang="en-US"/>
-              <a:t>ClosureCopilot · Mayuresh Piske · © 2026 Microsoft</a:t>
-            </a:r>
+            <a:endParaRPr lang="en-US"/>
           </a:p>
         </p:txBody>
       </p:sp>
@@ -1325,9 +739,10 @@
           <a:lstStyle/>
           <a:p>
             <a:r>
-              <a:rPr lang="en-US"/>
+              <a:rPr lang="en-US" smtClean="0"/>
               <a:t>Click to edit Master title style</a:t>
             </a:r>
+            <a:endParaRPr lang="en-US"/>
           </a:p>
         </p:txBody>
       </p:sp>
@@ -1348,37 +763,38 @@
           <a:p>
             <a:pPr lvl="0"/>
             <a:r>
-              <a:rPr lang="en-US"/>
+              <a:rPr lang="en-US" smtClean="0"/>
               <a:t>Click to edit Master text styles</a:t>
             </a:r>
           </a:p>
           <a:p>
             <a:pPr lvl="1"/>
             <a:r>
-              <a:rPr lang="en-US"/>
+              <a:rPr lang="en-US" smtClean="0"/>
               <a:t>Second level</a:t>
             </a:r>
           </a:p>
           <a:p>
             <a:pPr lvl="2"/>
             <a:r>
-              <a:rPr lang="en-US"/>
+              <a:rPr lang="en-US" smtClean="0"/>
               <a:t>Third level</a:t>
             </a:r>
           </a:p>
           <a:p>
             <a:pPr lvl="3"/>
             <a:r>
-              <a:rPr lang="en-US"/>
+              <a:rPr lang="en-US" smtClean="0"/>
               <a:t>Fourth level</a:t>
             </a:r>
           </a:p>
           <a:p>
             <a:pPr lvl="4"/>
             <a:r>
-              <a:rPr lang="en-US"/>
+              <a:rPr lang="en-US" smtClean="0"/>
               <a:t>Fifth level</a:t>
             </a:r>
+            <a:endParaRPr lang="en-US"/>
           </a:p>
         </p:txBody>
       </p:sp>
@@ -1397,9 +813,9 @@
           <a:bodyPr/>
           <a:lstStyle/>
           <a:p>
-            <a:fld id="{14366139-1F27-41D5-A69B-CA0FBF3AE9E0}" type="datetime1">
-              <a:rPr lang="en-US" smtClean="0"/>
-              <a:t>9/5/2026</a:t>
+            <a:fld id="{5BCAD085-E8A6-8845-BD4E-CB4CCA059FC4}" type="datetimeFigureOut">
+              <a:rPr lang="en-US" smtClean="0"/>
+              <a:t>1/27/13</a:t>
             </a:fld>
             <a:endParaRPr lang="en-US"/>
           </a:p>
@@ -1420,10 +836,7 @@
           <a:bodyPr/>
           <a:lstStyle/>
           <a:p>
-            <a:r>
-              <a:rPr lang="en-US"/>
-              <a:t>ClosureCopilot · Mayuresh Piske · © 2026 Microsoft</a:t>
-            </a:r>
+            <a:endParaRPr lang="en-US"/>
           </a:p>
         </p:txBody>
       </p:sp>
@@ -1505,9 +918,10 @@
           </a:lstStyle>
           <a:p>
             <a:r>
-              <a:rPr lang="en-US"/>
+              <a:rPr lang="en-US" smtClean="0"/>
               <a:t>Click to edit Master title style</a:t>
             </a:r>
+            <a:endParaRPr lang="en-US"/>
           </a:p>
         </p:txBody>
       </p:sp>
@@ -1624,7 +1038,7 @@
           <a:p>
             <a:pPr lvl="0"/>
             <a:r>
-              <a:rPr lang="en-US"/>
+              <a:rPr lang="en-US" smtClean="0"/>
               <a:t>Click to edit Master text styles</a:t>
             </a:r>
           </a:p>
@@ -1645,9 +1059,9 @@
           <a:bodyPr/>
           <a:lstStyle/>
           <a:p>
-            <a:fld id="{F4AD9446-3569-482E-B95D-099B6825A3EA}" type="datetime1">
-              <a:rPr lang="en-US" smtClean="0"/>
-              <a:t>9/5/2026</a:t>
+            <a:fld id="{5BCAD085-E8A6-8845-BD4E-CB4CCA059FC4}" type="datetimeFigureOut">
+              <a:rPr lang="en-US" smtClean="0"/>
+              <a:t>1/27/13</a:t>
             </a:fld>
             <a:endParaRPr lang="en-US"/>
           </a:p>
@@ -1668,10 +1082,7 @@
           <a:bodyPr/>
           <a:lstStyle/>
           <a:p>
-            <a:r>
-              <a:rPr lang="en-US"/>
-              <a:t>ClosureCopilot · Mayuresh Piske · © 2026 Microsoft</a:t>
-            </a:r>
+            <a:endParaRPr lang="en-US"/>
           </a:p>
         </p:txBody>
       </p:sp>
@@ -1744,9 +1155,10 @@
           <a:lstStyle/>
           <a:p>
             <a:r>
-              <a:rPr lang="en-US"/>
+              <a:rPr lang="en-US" smtClean="0"/>
               <a:t>Click to edit Master title style</a:t>
             </a:r>
+            <a:endParaRPr lang="en-US"/>
           </a:p>
         </p:txBody>
       </p:sp>
@@ -1800,37 +1212,38 @@
           <a:p>
             <a:pPr lvl="0"/>
             <a:r>
-              <a:rPr lang="en-US"/>
+              <a:rPr lang="en-US" smtClean="0"/>
               <a:t>Click to edit Master text styles</a:t>
             </a:r>
           </a:p>
           <a:p>
             <a:pPr lvl="1"/>
             <a:r>
-              <a:rPr lang="en-US"/>
+              <a:rPr lang="en-US" smtClean="0"/>
               <a:t>Second level</a:t>
             </a:r>
           </a:p>
           <a:p>
             <a:pPr lvl="2"/>
             <a:r>
-              <a:rPr lang="en-US"/>
+              <a:rPr lang="en-US" smtClean="0"/>
               <a:t>Third level</a:t>
             </a:r>
           </a:p>
           <a:p>
             <a:pPr lvl="3"/>
             <a:r>
-              <a:rPr lang="en-US"/>
+              <a:rPr lang="en-US" smtClean="0"/>
               <a:t>Fourth level</a:t>
             </a:r>
           </a:p>
           <a:p>
             <a:pPr lvl="4"/>
             <a:r>
-              <a:rPr lang="en-US"/>
+              <a:rPr lang="en-US" smtClean="0"/>
               <a:t>Fifth level</a:t>
             </a:r>
+            <a:endParaRPr lang="en-US"/>
           </a:p>
         </p:txBody>
       </p:sp>
@@ -1884,37 +1297,38 @@
           <a:p>
             <a:pPr lvl="0"/>
             <a:r>
-              <a:rPr lang="en-US"/>
+              <a:rPr lang="en-US" smtClean="0"/>
               <a:t>Click to edit Master text styles</a:t>
             </a:r>
           </a:p>
           <a:p>
             <a:pPr lvl="1"/>
             <a:r>
-              <a:rPr lang="en-US"/>
+              <a:rPr lang="en-US" smtClean="0"/>
               <a:t>Second level</a:t>
             </a:r>
           </a:p>
           <a:p>
             <a:pPr lvl="2"/>
             <a:r>
-              <a:rPr lang="en-US"/>
+              <a:rPr lang="en-US" smtClean="0"/>
               <a:t>Third level</a:t>
             </a:r>
           </a:p>
           <a:p>
             <a:pPr lvl="3"/>
             <a:r>
-              <a:rPr lang="en-US"/>
+              <a:rPr lang="en-US" smtClean="0"/>
               <a:t>Fourth level</a:t>
             </a:r>
           </a:p>
           <a:p>
             <a:pPr lvl="4"/>
             <a:r>
-              <a:rPr lang="en-US"/>
+              <a:rPr lang="en-US" smtClean="0"/>
               <a:t>Fifth level</a:t>
             </a:r>
+            <a:endParaRPr lang="en-US"/>
           </a:p>
         </p:txBody>
       </p:sp>
@@ -1933,9 +1347,9 @@
           <a:bodyPr/>
           <a:lstStyle/>
           <a:p>
-            <a:fld id="{1AA2D408-C22F-4865-A74C-8E62198A75B9}" type="datetime1">
-              <a:rPr lang="en-US" smtClean="0"/>
-              <a:t>9/5/2026</a:t>
+            <a:fld id="{5BCAD085-E8A6-8845-BD4E-CB4CCA059FC4}" type="datetimeFigureOut">
+              <a:rPr lang="en-US" smtClean="0"/>
+              <a:t>1/27/13</a:t>
             </a:fld>
             <a:endParaRPr lang="en-US"/>
           </a:p>
@@ -1956,10 +1370,7 @@
           <a:bodyPr/>
           <a:lstStyle/>
           <a:p>
-            <a:r>
-              <a:rPr lang="en-US"/>
-              <a:t>ClosureCopilot · Mayuresh Piske · © 2026 Microsoft</a:t>
-            </a:r>
+            <a:endParaRPr lang="en-US"/>
           </a:p>
         </p:txBody>
       </p:sp>
@@ -2036,9 +1447,10 @@
           </a:lstStyle>
           <a:p>
             <a:r>
-              <a:rPr lang="en-US"/>
+              <a:rPr lang="en-US" smtClean="0"/>
               <a:t>Click to edit Master title style</a:t>
             </a:r>
+            <a:endParaRPr lang="en-US"/>
           </a:p>
         </p:txBody>
       </p:sp>
@@ -2101,7 +1513,7 @@
           <a:p>
             <a:pPr lvl="0"/>
             <a:r>
-              <a:rPr lang="en-US"/>
+              <a:rPr lang="en-US" smtClean="0"/>
               <a:t>Click to edit Master text styles</a:t>
             </a:r>
           </a:p>
@@ -2157,37 +1569,38 @@
           <a:p>
             <a:pPr lvl="0"/>
             <a:r>
-              <a:rPr lang="en-US"/>
+              <a:rPr lang="en-US" smtClean="0"/>
               <a:t>Click to edit Master text styles</a:t>
             </a:r>
           </a:p>
           <a:p>
             <a:pPr lvl="1"/>
             <a:r>
-              <a:rPr lang="en-US"/>
+              <a:rPr lang="en-US" smtClean="0"/>
               <a:t>Second level</a:t>
             </a:r>
           </a:p>
           <a:p>
             <a:pPr lvl="2"/>
             <a:r>
-              <a:rPr lang="en-US"/>
+              <a:rPr lang="en-US" smtClean="0"/>
               <a:t>Third level</a:t>
             </a:r>
           </a:p>
           <a:p>
             <a:pPr lvl="3"/>
             <a:r>
-              <a:rPr lang="en-US"/>
+              <a:rPr lang="en-US" smtClean="0"/>
               <a:t>Fourth level</a:t>
             </a:r>
           </a:p>
           <a:p>
             <a:pPr lvl="4"/>
             <a:r>
-              <a:rPr lang="en-US"/>
+              <a:rPr lang="en-US" smtClean="0"/>
               <a:t>Fifth level</a:t>
             </a:r>
+            <a:endParaRPr lang="en-US"/>
           </a:p>
         </p:txBody>
       </p:sp>
@@ -2250,7 +1663,7 @@
           <a:p>
             <a:pPr lvl="0"/>
             <a:r>
-              <a:rPr lang="en-US"/>
+              <a:rPr lang="en-US" smtClean="0"/>
               <a:t>Click to edit Master text styles</a:t>
             </a:r>
           </a:p>
@@ -2306,37 +1719,38 @@
           <a:p>
             <a:pPr lvl="0"/>
             <a:r>
-              <a:rPr lang="en-US"/>
+              <a:rPr lang="en-US" smtClean="0"/>
               <a:t>Click to edit Master text styles</a:t>
             </a:r>
           </a:p>
           <a:p>
             <a:pPr lvl="1"/>
             <a:r>
-              <a:rPr lang="en-US"/>
+              <a:rPr lang="en-US" smtClean="0"/>
               <a:t>Second level</a:t>
             </a:r>
           </a:p>
           <a:p>
             <a:pPr lvl="2"/>
             <a:r>
-              <a:rPr lang="en-US"/>
+              <a:rPr lang="en-US" smtClean="0"/>
               <a:t>Third level</a:t>
             </a:r>
           </a:p>
           <a:p>
             <a:pPr lvl="3"/>
             <a:r>
-              <a:rPr lang="en-US"/>
+              <a:rPr lang="en-US" smtClean="0"/>
               <a:t>Fourth level</a:t>
             </a:r>
           </a:p>
           <a:p>
             <a:pPr lvl="4"/>
             <a:r>
-              <a:rPr lang="en-US"/>
+              <a:rPr lang="en-US" smtClean="0"/>
               <a:t>Fifth level</a:t>
             </a:r>
+            <a:endParaRPr lang="en-US"/>
           </a:p>
         </p:txBody>
       </p:sp>
@@ -2355,9 +1769,9 @@
           <a:bodyPr/>
           <a:lstStyle/>
           <a:p>
-            <a:fld id="{7FC42C51-E0FA-49C8-BD77-1A8E329A1E2C}" type="datetime1">
-              <a:rPr lang="en-US" smtClean="0"/>
-              <a:t>9/5/2026</a:t>
+            <a:fld id="{5BCAD085-E8A6-8845-BD4E-CB4CCA059FC4}" type="datetimeFigureOut">
+              <a:rPr lang="en-US" smtClean="0"/>
+              <a:t>1/27/13</a:t>
             </a:fld>
             <a:endParaRPr lang="en-US"/>
           </a:p>
@@ -2378,10 +1792,7 @@
           <a:bodyPr/>
           <a:lstStyle/>
           <a:p>
-            <a:r>
-              <a:rPr lang="en-US"/>
-              <a:t>ClosureCopilot · Mayuresh Piske · © 2026 Microsoft</a:t>
-            </a:r>
+            <a:endParaRPr lang="en-US"/>
           </a:p>
         </p:txBody>
       </p:sp>
@@ -2454,9 +1865,10 @@
           <a:lstStyle/>
           <a:p>
             <a:r>
-              <a:rPr lang="en-US"/>
+              <a:rPr lang="en-US" smtClean="0"/>
               <a:t>Click to edit Master title style</a:t>
             </a:r>
+            <a:endParaRPr lang="en-US"/>
           </a:p>
         </p:txBody>
       </p:sp>
@@ -2475,9 +1887,9 @@
           <a:bodyPr/>
           <a:lstStyle/>
           <a:p>
-            <a:fld id="{42FEB809-D8AE-458D-A09F-EC991CDFAAF4}" type="datetime1">
-              <a:rPr lang="en-US" smtClean="0"/>
-              <a:t>9/5/2026</a:t>
+            <a:fld id="{5BCAD085-E8A6-8845-BD4E-CB4CCA059FC4}" type="datetimeFigureOut">
+              <a:rPr lang="en-US" smtClean="0"/>
+              <a:t>1/27/13</a:t>
             </a:fld>
             <a:endParaRPr lang="en-US"/>
           </a:p>
@@ -2498,10 +1910,7 @@
           <a:bodyPr/>
           <a:lstStyle/>
           <a:p>
-            <a:r>
-              <a:rPr lang="en-US"/>
-              <a:t>ClosureCopilot · Mayuresh Piske · © 2026 Microsoft</a:t>
-            </a:r>
+            <a:endParaRPr lang="en-US"/>
           </a:p>
         </p:txBody>
       </p:sp>
@@ -2573,9 +1982,9 @@
           <a:bodyPr/>
           <a:lstStyle/>
           <a:p>
-            <a:fld id="{AC27DD57-8BD2-4ABC-907F-600A7AE12FA9}" type="datetime1">
-              <a:rPr lang="en-US" smtClean="0"/>
-              <a:t>9/5/2026</a:t>
+            <a:fld id="{5BCAD085-E8A6-8845-BD4E-CB4CCA059FC4}" type="datetimeFigureOut">
+              <a:rPr lang="en-US" smtClean="0"/>
+              <a:t>1/27/13</a:t>
             </a:fld>
             <a:endParaRPr lang="en-US"/>
           </a:p>
@@ -2596,10 +2005,7 @@
           <a:bodyPr/>
           <a:lstStyle/>
           <a:p>
-            <a:r>
-              <a:rPr lang="en-US"/>
-              <a:t>ClosureCopilot · Mayuresh Piske · © 2026 Microsoft</a:t>
-            </a:r>
+            <a:endParaRPr lang="en-US"/>
           </a:p>
         </p:txBody>
       </p:sp>
@@ -2681,9 +2087,10 @@
           </a:lstStyle>
           <a:p>
             <a:r>
-              <a:rPr lang="en-US"/>
+              <a:rPr lang="en-US" smtClean="0"/>
               <a:t>Click to edit Master title style</a:t>
             </a:r>
+            <a:endParaRPr lang="en-US"/>
           </a:p>
         </p:txBody>
       </p:sp>
@@ -2737,37 +2144,38 @@
           <a:p>
             <a:pPr lvl="0"/>
             <a:r>
-              <a:rPr lang="en-US"/>
+              <a:rPr lang="en-US" smtClean="0"/>
               <a:t>Click to edit Master text styles</a:t>
             </a:r>
           </a:p>
           <a:p>
             <a:pPr lvl="1"/>
             <a:r>
-              <a:rPr lang="en-US"/>
+              <a:rPr lang="en-US" smtClean="0"/>
               <a:t>Second level</a:t>
             </a:r>
           </a:p>
           <a:p>
             <a:pPr lvl="2"/>
             <a:r>
-              <a:rPr lang="en-US"/>
+              <a:rPr lang="en-US" smtClean="0"/>
               <a:t>Third level</a:t>
             </a:r>
           </a:p>
           <a:p>
             <a:pPr lvl="3"/>
             <a:r>
-              <a:rPr lang="en-US"/>
+              <a:rPr lang="en-US" smtClean="0"/>
               <a:t>Fourth level</a:t>
             </a:r>
           </a:p>
           <a:p>
             <a:pPr lvl="4"/>
             <a:r>
-              <a:rPr lang="en-US"/>
+              <a:rPr lang="en-US" smtClean="0"/>
               <a:t>Fifth level</a:t>
             </a:r>
+            <a:endParaRPr lang="en-US"/>
           </a:p>
         </p:txBody>
       </p:sp>
@@ -2830,7 +2238,7 @@
           <a:p>
             <a:pPr lvl="0"/>
             <a:r>
-              <a:rPr lang="en-US"/>
+              <a:rPr lang="en-US" smtClean="0"/>
               <a:t>Click to edit Master text styles</a:t>
             </a:r>
           </a:p>
@@ -2851,9 +2259,9 @@
           <a:bodyPr/>
           <a:lstStyle/>
           <a:p>
-            <a:fld id="{05D9FBC0-417F-4E6F-BB0A-C044624887C5}" type="datetime1">
-              <a:rPr lang="en-US" smtClean="0"/>
-              <a:t>9/5/2026</a:t>
+            <a:fld id="{5BCAD085-E8A6-8845-BD4E-CB4CCA059FC4}" type="datetimeFigureOut">
+              <a:rPr lang="en-US" smtClean="0"/>
+              <a:t>1/27/13</a:t>
             </a:fld>
             <a:endParaRPr lang="en-US"/>
           </a:p>
@@ -2874,10 +2282,7 @@
           <a:bodyPr/>
           <a:lstStyle/>
           <a:p>
-            <a:r>
-              <a:rPr lang="en-US"/>
-              <a:t>ClosureCopilot · Mayuresh Piske · © 2026 Microsoft</a:t>
-            </a:r>
+            <a:endParaRPr lang="en-US"/>
           </a:p>
         </p:txBody>
       </p:sp>
@@ -2959,9 +2364,10 @@
           </a:lstStyle>
           <a:p>
             <a:r>
-              <a:rPr lang="en-US"/>
+              <a:rPr lang="en-US" smtClean="0"/>
               <a:t>Click to edit Master title style</a:t>
             </a:r>
+            <a:endParaRPr lang="en-US"/>
           </a:p>
         </p:txBody>
       </p:sp>
@@ -3085,7 +2491,7 @@
           <a:p>
             <a:pPr lvl="0"/>
             <a:r>
-              <a:rPr lang="en-US"/>
+              <a:rPr lang="en-US" smtClean="0"/>
               <a:t>Click to edit Master text styles</a:t>
             </a:r>
           </a:p>
@@ -3106,9 +2512,9 @@
           <a:bodyPr/>
           <a:lstStyle/>
           <a:p>
-            <a:fld id="{10E24268-1955-4D60-8C2B-6482ABF32B4B}" type="datetime1">
-              <a:rPr lang="en-US" smtClean="0"/>
-              <a:t>9/5/2026</a:t>
+            <a:fld id="{5BCAD085-E8A6-8845-BD4E-CB4CCA059FC4}" type="datetimeFigureOut">
+              <a:rPr lang="en-US" smtClean="0"/>
+              <a:t>1/27/13</a:t>
             </a:fld>
             <a:endParaRPr lang="en-US"/>
           </a:p>
@@ -3129,10 +2535,7 @@
           <a:bodyPr/>
           <a:lstStyle/>
           <a:p>
-            <a:r>
-              <a:rPr lang="en-US"/>
-              <a:t>ClosureCopilot · Mayuresh Piske · © 2026 Microsoft</a:t>
-            </a:r>
+            <a:endParaRPr lang="en-US"/>
           </a:p>
         </p:txBody>
       </p:sp>
@@ -3220,9 +2623,10 @@
           <a:lstStyle/>
           <a:p>
             <a:r>
-              <a:rPr lang="en-US"/>
+              <a:rPr lang="en-US" smtClean="0"/>
               <a:t>Click to edit Master title style</a:t>
             </a:r>
+            <a:endParaRPr lang="en-US"/>
           </a:p>
         </p:txBody>
       </p:sp>
@@ -3253,37 +2657,38 @@
           <a:p>
             <a:pPr lvl="0"/>
             <a:r>
-              <a:rPr lang="en-US"/>
+              <a:rPr lang="en-US" smtClean="0"/>
               <a:t>Click to edit Master text styles</a:t>
             </a:r>
           </a:p>
           <a:p>
             <a:pPr lvl="1"/>
             <a:r>
-              <a:rPr lang="en-US"/>
+              <a:rPr lang="en-US" smtClean="0"/>
               <a:t>Second level</a:t>
             </a:r>
           </a:p>
           <a:p>
             <a:pPr lvl="2"/>
             <a:r>
-              <a:rPr lang="en-US"/>
+              <a:rPr lang="en-US" smtClean="0"/>
               <a:t>Third level</a:t>
             </a:r>
           </a:p>
           <a:p>
             <a:pPr lvl="3"/>
             <a:r>
-              <a:rPr lang="en-US"/>
+              <a:rPr lang="en-US" smtClean="0"/>
               <a:t>Fourth level</a:t>
             </a:r>
           </a:p>
           <a:p>
             <a:pPr lvl="4"/>
             <a:r>
-              <a:rPr lang="en-US"/>
+              <a:rPr lang="en-US" smtClean="0"/>
               <a:t>Fifth level</a:t>
             </a:r>
+            <a:endParaRPr lang="en-US"/>
           </a:p>
         </p:txBody>
       </p:sp>
@@ -3320,9 +2725,9 @@
             </a:lvl1pPr>
           </a:lstStyle>
           <a:p>
-            <a:fld id="{84F916B1-F069-4B57-8997-E8307208C489}" type="datetime1">
-              <a:rPr lang="en-US" smtClean="0"/>
-              <a:t>9/5/2026</a:t>
+            <a:fld id="{5BCAD085-E8A6-8845-BD4E-CB4CCA059FC4}" type="datetimeFigureOut">
+              <a:rPr lang="en-US" smtClean="0"/>
+              <a:t>1/27/13</a:t>
             </a:fld>
             <a:endParaRPr lang="en-US"/>
           </a:p>
@@ -3361,10 +2766,7 @@
             </a:lvl1pPr>
           </a:lstStyle>
           <a:p>
-            <a:r>
-              <a:rPr lang="en-US"/>
-              <a:t>ClosureCopilot · Mayuresh Piske · © 2026 Microsoft</a:t>
-            </a:r>
+            <a:endParaRPr lang="en-US"/>
           </a:p>
         </p:txBody>
       </p:sp>
@@ -3430,7 +2832,6 @@
     <p:sldLayoutId id="2147483658" r:id="rId10"/>
     <p:sldLayoutId id="2147483659" r:id="rId11"/>
   </p:sldLayoutIdLst>
-  <p:hf hdr="0" dt="0"/>
   <p:txStyles>
     <p:titleStyle>
       <a:lvl1pPr algn="ctr" defTabSz="457200" rtl="0" eaLnBrk="1" latinLnBrk="0" hangingPunct="1">
@@ -3685,7 +3086,7 @@
 </file>
 
 <file path=ppt/slides/slide1.xml><?xml version="1.0" encoding="utf-8"?>
-<p:sld xmlns:a="http://schemas.openxmlformats.org/drawingml/2006/main" xmlns:r="http://schemas.openxmlformats.org/officeDocument/2006/relationships" xmlns:p="http://schemas.openxmlformats.org/presentationml/2006/main">
+<p:sld xmlns:a="http://schemas.openxmlformats.org/drawingml/2006/main" xmlns:p="http://schemas.openxmlformats.org/presentationml/2006/main" xmlns:r="http://schemas.openxmlformats.org/officeDocument/2006/relationships">
   <p:cSld>
     <p:spTree>
       <p:nvGrpSpPr>
@@ -3693,14 +3094,7 @@
         <p:cNvGrpSpPr/>
         <p:nvPr/>
       </p:nvGrpSpPr>
-      <p:grpSpPr>
-        <a:xfrm>
-          <a:off x="0" y="0"/>
-          <a:ext cx="0" cy="0"/>
-          <a:chOff x="0" y="0"/>
-          <a:chExt cx="0" cy="0"/>
-        </a:xfrm>
-      </p:grpSpPr>
+      <p:grpSpPr/>
       <p:sp>
         <p:nvSpPr>
           <p:cNvPr id="2" name="Rounded Rectangle 1"/>
@@ -3742,7 +3136,6 @@
           <a:lstStyle/>
           <a:p>
             <a:pPr algn="ctr"/>
-            <a:endParaRPr/>
           </a:p>
         </p:txBody>
       </p:sp>
@@ -3787,7 +3180,6 @@
           <a:lstStyle/>
           <a:p>
             <a:pPr algn="ctr"/>
-            <a:endParaRPr/>
           </a:p>
         </p:txBody>
       </p:sp>
@@ -3832,7 +3224,6 @@
           <a:lstStyle/>
           <a:p>
             <a:pPr algn="ctr"/>
-            <a:endParaRPr/>
           </a:p>
         </p:txBody>
       </p:sp>
@@ -3895,7 +3286,7 @@
           <a:p>
             <a:pPr algn="l"/>
             <a:r>
-              <a:rPr sz="2600" b="1" dirty="0">
+              <a:rPr sz="2600" b="1">
                 <a:solidFill>
                   <a:srgbClr val="BFD4F2"/>
                 </a:solidFill>
@@ -3930,7 +3321,7 @@
           <a:p>
             <a:pPr algn="l"/>
             <a:r>
-              <a:rPr sz="2000" b="0" dirty="0">
+              <a:rPr sz="2000" b="0">
                 <a:solidFill>
                   <a:srgbClr val="9FB8E0"/>
                 </a:solidFill>
@@ -3938,82 +3329,6 @@
               </a:rPr>
               <a:t>It decides WHERE each fix belongs — RTL  ·  SDC  ·  UPF</a:t>
             </a:r>
-          </a:p>
-        </p:txBody>
-      </p:sp>
-      <p:sp>
-        <p:nvSpPr>
-          <p:cNvPr id="11" name="TextBox 10">
-            <a:extLst>
-              <a:ext uri="{FF2B5EF4-FFF2-40B4-BE49-F238E27FC236}">
-                <a16:creationId xmlns:a16="http://schemas.microsoft.com/office/drawing/2014/main" id="{B25F93AE-AE4B-0369-7B8A-DF9D4A6D992F}"/>
-              </a:ext>
-            </a:extLst>
-          </p:cNvPr>
-          <p:cNvSpPr txBox="1"/>
-          <p:nvPr/>
-        </p:nvSpPr>
-        <p:spPr>
-          <a:xfrm>
-            <a:off x="868680" y="5921262"/>
-            <a:ext cx="10515600" cy="400110"/>
-          </a:xfrm>
-          <a:prstGeom prst="rect">
-            <a:avLst/>
-          </a:prstGeom>
-          <a:noFill/>
-        </p:spPr>
-        <p:txBody>
-          <a:bodyPr wrap="square" anchor="t">
-            <a:spAutoFit/>
-          </a:bodyPr>
-          <a:lstStyle/>
-          <a:p>
-            <a:pPr algn="l"/>
-            <a:r>
-              <a:rPr lang="en-IN" sz="2000" b="1" dirty="0">
-                <a:solidFill>
-                  <a:srgbClr val="BFD4F2"/>
-                </a:solidFill>
-                <a:latin typeface="Segoe UI"/>
-              </a:rPr>
-              <a:t>Mayuresh Piske</a:t>
-            </a:r>
-            <a:endParaRPr sz="2000" b="1" dirty="0">
-              <a:solidFill>
-                <a:srgbClr val="BFD4F2"/>
-              </a:solidFill>
-              <a:latin typeface="Segoe UI"/>
-            </a:endParaRPr>
-          </a:p>
-        </p:txBody>
-      </p:sp>
-      <p:sp>
-        <p:nvSpPr>
-          <p:cNvPr id="13" name="Slide Number Placeholder 12">
-            <a:extLst>
-              <a:ext uri="{FF2B5EF4-FFF2-40B4-BE49-F238E27FC236}">
-                <a16:creationId xmlns:a16="http://schemas.microsoft.com/office/drawing/2014/main" id="{AE762DB3-6B60-B04A-6D8B-ADDDF3DC6497}"/>
-              </a:ext>
-            </a:extLst>
-          </p:cNvPr>
-          <p:cNvSpPr>
-            <a:spLocks noGrp="1"/>
-          </p:cNvSpPr>
-          <p:nvPr>
-            <p:ph type="sldNum" sz="quarter" idx="12"/>
-          </p:nvPr>
-        </p:nvSpPr>
-        <p:spPr/>
-        <p:txBody>
-          <a:bodyPr/>
-          <a:lstStyle/>
-          <a:p>
-            <a:fld id="{C1FF6DA9-008F-8B48-92A6-B652298478BF}" type="slidenum">
-              <a:rPr lang="en-US" smtClean="0"/>
-              <a:t>1</a:t>
-            </a:fld>
-            <a:endParaRPr lang="en-US"/>
           </a:p>
         </p:txBody>
       </p:sp>
@@ -4026,7 +3341,7 @@
 </file>
 
 <file path=ppt/slides/slide2.xml><?xml version="1.0" encoding="utf-8"?>
-<p:sld xmlns:a="http://schemas.openxmlformats.org/drawingml/2006/main" xmlns:r="http://schemas.openxmlformats.org/officeDocument/2006/relationships" xmlns:p="http://schemas.openxmlformats.org/presentationml/2006/main">
+<p:sld xmlns:a="http://schemas.openxmlformats.org/drawingml/2006/main" xmlns:p="http://schemas.openxmlformats.org/presentationml/2006/main" xmlns:r="http://schemas.openxmlformats.org/officeDocument/2006/relationships">
   <p:cSld>
     <p:spTree>
       <p:nvGrpSpPr>
@@ -4034,14 +3349,51 @@
         <p:cNvGrpSpPr/>
         <p:nvPr/>
       </p:nvGrpSpPr>
-      <p:grpSpPr>
-        <a:xfrm>
-          <a:off x="0" y="0"/>
-          <a:ext cx="0" cy="0"/>
-          <a:chOff x="0" y="0"/>
-          <a:chExt cx="0" cy="0"/>
-        </a:xfrm>
-      </p:grpSpPr>
+      <p:grpSpPr/>
+      <p:sp>
+        <p:nvSpPr>
+          <p:cNvPr id="2" name="Rounded Rectangle 1"/>
+          <p:cNvSpPr/>
+          <p:nvPr/>
+        </p:nvSpPr>
+        <p:spPr>
+          <a:xfrm>
+            <a:off x="0" y="0"/>
+            <a:ext cx="12191695" cy="6858000"/>
+          </a:xfrm>
+          <a:prstGeom prst="roundRect">
+            <a:avLst/>
+          </a:prstGeom>
+          <a:solidFill>
+            <a:srgbClr val="FFFFFF"/>
+          </a:solidFill>
+          <a:ln>
+            <a:noFill/>
+          </a:ln>
+          <a:effectLst/>
+        </p:spPr>
+        <p:style>
+          <a:lnRef idx="1">
+            <a:schemeClr val="accent1"/>
+          </a:lnRef>
+          <a:fillRef idx="3">
+            <a:schemeClr val="accent1"/>
+          </a:fillRef>
+          <a:effectRef idx="2">
+            <a:schemeClr val="accent1"/>
+          </a:effectRef>
+          <a:fontRef idx="minor">
+            <a:schemeClr val="lt1"/>
+          </a:fontRef>
+        </p:style>
+        <p:txBody>
+          <a:bodyPr rtlCol="0" anchor="ctr"/>
+          <a:lstStyle/>
+          <a:p>
+            <a:pPr algn="ctr"/>
+          </a:p>
+        </p:txBody>
+      </p:sp>
       <p:sp>
         <p:nvSpPr>
           <p:cNvPr id="3" name="Rounded Rectangle 2"/>
@@ -4083,7 +3435,6 @@
           <a:lstStyle/>
           <a:p>
             <a:pPr algn="ctr"/>
-            <a:endParaRPr/>
           </a:p>
         </p:txBody>
       </p:sp>
@@ -4124,7 +3475,42 @@
       </p:sp>
       <p:sp>
         <p:nvSpPr>
-          <p:cNvPr id="5" name="Rounded Rectangle 4"/>
+          <p:cNvPr id="5" name="TextBox 4"/>
+          <p:cNvSpPr txBox="1"/>
+          <p:nvPr/>
+        </p:nvSpPr>
+        <p:spPr>
+          <a:xfrm>
+            <a:off x="5486400" y="6473952"/>
+            <a:ext cx="6519672" cy="292608"/>
+          </a:xfrm>
+          <a:prstGeom prst="rect">
+            <a:avLst/>
+          </a:prstGeom>
+          <a:noFill/>
+        </p:spPr>
+        <p:txBody>
+          <a:bodyPr wrap="none">
+            <a:spAutoFit/>
+          </a:bodyPr>
+          <a:lstStyle/>
+          <a:p>
+            <a:pPr algn="r"/>
+            <a:r>
+              <a:rPr sz="900">
+                <a:solidFill>
+                  <a:srgbClr val="57606A"/>
+                </a:solidFill>
+                <a:latin typeface="Segoe UI"/>
+              </a:rPr>
+              <a:t>ClosureCopilot · Mayuresh Piske · © 2026 Microsoft</a:t>
+            </a:r>
+          </a:p>
+        </p:txBody>
+      </p:sp>
+      <p:sp>
+        <p:nvSpPr>
+          <p:cNvPr id="6" name="Rounded Rectangle 5"/>
           <p:cNvSpPr/>
           <p:nvPr/>
         </p:nvSpPr>
@@ -4163,13 +3549,12 @@
           <a:lstStyle/>
           <a:p>
             <a:pPr algn="ctr"/>
-            <a:endParaRPr/>
-          </a:p>
-        </p:txBody>
-      </p:sp>
-      <p:sp>
-        <p:nvSpPr>
-          <p:cNvPr id="6" name="TextBox 5"/>
+          </a:p>
+        </p:txBody>
+      </p:sp>
+      <p:sp>
+        <p:nvSpPr>
+          <p:cNvPr id="7" name="TextBox 6"/>
           <p:cNvSpPr txBox="1"/>
           <p:nvPr/>
         </p:nvSpPr>
@@ -4204,7 +3589,7 @@
       </p:sp>
       <p:sp>
         <p:nvSpPr>
-          <p:cNvPr id="7" name="Rounded Rectangle 6"/>
+          <p:cNvPr id="8" name="Rounded Rectangle 7"/>
           <p:cNvSpPr/>
           <p:nvPr/>
         </p:nvSpPr>
@@ -4243,13 +3628,12 @@
           <a:lstStyle/>
           <a:p>
             <a:pPr algn="ctr"/>
-            <a:endParaRPr/>
-          </a:p>
-        </p:txBody>
-      </p:sp>
-      <p:sp>
-        <p:nvSpPr>
-          <p:cNvPr id="8" name="TextBox 7"/>
+          </a:p>
+        </p:txBody>
+      </p:sp>
+      <p:sp>
+        <p:nvSpPr>
+          <p:cNvPr id="9" name="TextBox 8"/>
           <p:cNvSpPr txBox="1"/>
           <p:nvPr/>
         </p:nvSpPr>
@@ -4284,7 +3668,7 @@
       </p:sp>
       <p:sp>
         <p:nvSpPr>
-          <p:cNvPr id="9" name="Rounded Rectangle 8"/>
+          <p:cNvPr id="10" name="Rounded Rectangle 9"/>
           <p:cNvSpPr/>
           <p:nvPr/>
         </p:nvSpPr>
@@ -4323,13 +3707,12 @@
           <a:lstStyle/>
           <a:p>
             <a:pPr algn="ctr"/>
-            <a:endParaRPr/>
-          </a:p>
-        </p:txBody>
-      </p:sp>
-      <p:sp>
-        <p:nvSpPr>
-          <p:cNvPr id="10" name="TextBox 9"/>
+          </a:p>
+        </p:txBody>
+      </p:sp>
+      <p:sp>
+        <p:nvSpPr>
+          <p:cNvPr id="11" name="TextBox 10"/>
           <p:cNvSpPr txBox="1"/>
           <p:nvPr/>
         </p:nvSpPr>
@@ -4364,7 +3747,7 @@
       </p:sp>
       <p:sp>
         <p:nvSpPr>
-          <p:cNvPr id="11" name="Rounded Rectangle 10"/>
+          <p:cNvPr id="12" name="Rounded Rectangle 11"/>
           <p:cNvSpPr/>
           <p:nvPr/>
         </p:nvSpPr>
@@ -4403,13 +3786,12 @@
           <a:lstStyle/>
           <a:p>
             <a:pPr algn="ctr"/>
-            <a:endParaRPr/>
-          </a:p>
-        </p:txBody>
-      </p:sp>
-      <p:sp>
-        <p:nvSpPr>
-          <p:cNvPr id="12" name="TextBox 11"/>
+          </a:p>
+        </p:txBody>
+      </p:sp>
+      <p:sp>
+        <p:nvSpPr>
+          <p:cNvPr id="13" name="TextBox 12"/>
           <p:cNvSpPr txBox="1"/>
           <p:nvPr/>
         </p:nvSpPr>
@@ -4439,72 +3821,6 @@
               </a:rPr>
               <a:t>That expertise lives only in senior engineers' heads — and doesn't scale.</a:t>
             </a:r>
-          </a:p>
-        </p:txBody>
-      </p:sp>
-      <p:sp>
-        <p:nvSpPr>
-          <p:cNvPr id="13" name="Footer Placeholder 12">
-            <a:extLst>
-              <a:ext uri="{FF2B5EF4-FFF2-40B4-BE49-F238E27FC236}">
-                <a16:creationId xmlns:a16="http://schemas.microsoft.com/office/drawing/2014/main" id="{2CD06639-3C8E-33C0-FE69-B7ADA560992A}"/>
-              </a:ext>
-            </a:extLst>
-          </p:cNvPr>
-          <p:cNvSpPr>
-            <a:spLocks noGrp="1"/>
-          </p:cNvSpPr>
-          <p:nvPr>
-            <p:ph type="ftr" sz="quarter" idx="11"/>
-          </p:nvPr>
-        </p:nvSpPr>
-        <p:spPr>
-          <a:xfrm>
-            <a:off x="640080" y="6356350"/>
-            <a:ext cx="2653848" cy="365125"/>
-          </a:xfrm>
-        </p:spPr>
-        <p:txBody>
-          <a:bodyPr/>
-          <a:lstStyle/>
-          <a:p>
-            <a:r>
-              <a:rPr lang="en-US" dirty="0" err="1"/>
-              <a:t>ClosureCopilot</a:t>
-            </a:r>
-            <a:r>
-              <a:rPr lang="en-US" dirty="0"/>
-              <a:t> · © 2026 Microsoft</a:t>
-            </a:r>
-          </a:p>
-        </p:txBody>
-      </p:sp>
-      <p:sp>
-        <p:nvSpPr>
-          <p:cNvPr id="14" name="Slide Number Placeholder 13">
-            <a:extLst>
-              <a:ext uri="{FF2B5EF4-FFF2-40B4-BE49-F238E27FC236}">
-                <a16:creationId xmlns:a16="http://schemas.microsoft.com/office/drawing/2014/main" id="{58B4D48A-0156-D948-50BE-043CEEBF14D1}"/>
-              </a:ext>
-            </a:extLst>
-          </p:cNvPr>
-          <p:cNvSpPr>
-            <a:spLocks noGrp="1"/>
-          </p:cNvSpPr>
-          <p:nvPr>
-            <p:ph type="sldNum" sz="quarter" idx="12"/>
-          </p:nvPr>
-        </p:nvSpPr>
-        <p:spPr/>
-        <p:txBody>
-          <a:bodyPr/>
-          <a:lstStyle/>
-          <a:p>
-            <a:fld id="{C1FF6DA9-008F-8B48-92A6-B652298478BF}" type="slidenum">
-              <a:rPr lang="en-US" smtClean="0"/>
-              <a:t>2</a:t>
-            </a:fld>
-            <a:endParaRPr lang="en-US"/>
           </a:p>
         </p:txBody>
       </p:sp>
@@ -4517,7 +3833,7 @@
 </file>
 
 <file path=ppt/slides/slide3.xml><?xml version="1.0" encoding="utf-8"?>
-<p:sld xmlns:a="http://schemas.openxmlformats.org/drawingml/2006/main" xmlns:r="http://schemas.openxmlformats.org/officeDocument/2006/relationships" xmlns:p="http://schemas.openxmlformats.org/presentationml/2006/main">
+<p:sld xmlns:a="http://schemas.openxmlformats.org/drawingml/2006/main" xmlns:p="http://schemas.openxmlformats.org/presentationml/2006/main" xmlns:r="http://schemas.openxmlformats.org/officeDocument/2006/relationships">
   <p:cSld>
     <p:spTree>
       <p:nvGrpSpPr>
@@ -4525,14 +3841,7 @@
         <p:cNvGrpSpPr/>
         <p:nvPr/>
       </p:nvGrpSpPr>
-      <p:grpSpPr>
-        <a:xfrm>
-          <a:off x="0" y="0"/>
-          <a:ext cx="0" cy="0"/>
-          <a:chOff x="0" y="0"/>
-          <a:chExt cx="0" cy="0"/>
-        </a:xfrm>
-      </p:grpSpPr>
+      <p:grpSpPr/>
       <p:sp>
         <p:nvSpPr>
           <p:cNvPr id="2" name="Rounded Rectangle 1"/>
@@ -4574,7 +3883,6 @@
           <a:lstStyle/>
           <a:p>
             <a:pPr algn="ctr"/>
-            <a:endParaRPr/>
           </a:p>
         </p:txBody>
       </p:sp>
@@ -4619,7 +3927,6 @@
           <a:lstStyle/>
           <a:p>
             <a:pPr algn="ctr"/>
-            <a:endParaRPr/>
           </a:p>
         </p:txBody>
       </p:sp>
@@ -4631,8 +3938,8 @@
         </p:nvSpPr>
         <p:spPr>
           <a:xfrm>
-            <a:off x="548640" y="253353"/>
-            <a:ext cx="10972800" cy="553998"/>
+            <a:off x="548640" y="164592"/>
+            <a:ext cx="10972800" cy="731520"/>
           </a:xfrm>
           <a:prstGeom prst="rect">
             <a:avLst/>
@@ -4647,38 +3954,55 @@
           <a:p>
             <a:pPr algn="l"/>
             <a:r>
-              <a:rPr sz="3000" b="1" dirty="0">
+              <a:rPr sz="3000" b="1">
                 <a:solidFill>
                   <a:srgbClr val="FFFFFF"/>
                 </a:solidFill>
                 <a:latin typeface="Segoe UI"/>
               </a:rPr>
-              <a:t>One copilot · </a:t>
-            </a:r>
-            <a:r>
-              <a:rPr lang="en-IN" sz="3000" b="1">
-                <a:solidFill>
-                  <a:srgbClr val="FFFFFF"/>
+              <a:t>One copilot · 9 agents · any backend report</a:t>
+            </a:r>
+          </a:p>
+        </p:txBody>
+      </p:sp>
+      <p:sp>
+        <p:nvSpPr>
+          <p:cNvPr id="5" name="TextBox 4"/>
+          <p:cNvSpPr txBox="1"/>
+          <p:nvPr/>
+        </p:nvSpPr>
+        <p:spPr>
+          <a:xfrm>
+            <a:off x="5486400" y="6473952"/>
+            <a:ext cx="6519672" cy="292608"/>
+          </a:xfrm>
+          <a:prstGeom prst="rect">
+            <a:avLst/>
+          </a:prstGeom>
+          <a:noFill/>
+        </p:spPr>
+        <p:txBody>
+          <a:bodyPr wrap="none">
+            <a:spAutoFit/>
+          </a:bodyPr>
+          <a:lstStyle/>
+          <a:p>
+            <a:pPr algn="r"/>
+            <a:r>
+              <a:rPr sz="900">
+                <a:solidFill>
+                  <a:srgbClr val="57606A"/>
                 </a:solidFill>
                 <a:latin typeface="Segoe UI"/>
               </a:rPr>
-              <a:t>multi</a:t>
-            </a:r>
-            <a:r>
-              <a:rPr sz="3000" b="1">
-                <a:solidFill>
-                  <a:srgbClr val="FFFFFF"/>
-                </a:solidFill>
-                <a:latin typeface="Segoe UI"/>
-              </a:rPr>
-              <a:t> agents · any backend report</a:t>
+              <a:t>ClosureCopilot · Mayuresh Piske · © 2026 Microsoft</a:t>
             </a:r>
           </a:p>
         </p:txBody>
       </p:sp>
       <p:pic>
         <p:nvPicPr>
-          <p:cNvPr id="5" name="Picture 4" descr="architecture.png"/>
+          <p:cNvPr id="6" name="Picture 5" descr="architecture.png"/>
           <p:cNvPicPr>
             <a:picLocks noChangeAspect="1"/>
           </p:cNvPicPr>
@@ -4692,115 +4016,14 @@
         </p:blipFill>
         <p:spPr>
           <a:xfrm>
-            <a:off x="2104371" y="1060704"/>
-            <a:ext cx="7511205" cy="5327178"/>
+            <a:off x="2148840" y="1170432"/>
+            <a:ext cx="7669635" cy="5257800"/>
           </a:xfrm>
           <a:prstGeom prst="rect">
             <a:avLst/>
           </a:prstGeom>
         </p:spPr>
       </p:pic>
-      <p:sp>
-        <p:nvSpPr>
-          <p:cNvPr id="6" name="TextBox 5"/>
-          <p:cNvSpPr txBox="1"/>
-          <p:nvPr/>
-        </p:nvSpPr>
-        <p:spPr>
-          <a:xfrm>
-            <a:off x="640080" y="6355080"/>
-            <a:ext cx="10972800" cy="365760"/>
-          </a:xfrm>
-          <a:prstGeom prst="rect">
-            <a:avLst/>
-          </a:prstGeom>
-          <a:noFill/>
-        </p:spPr>
-        <p:txBody>
-          <a:bodyPr wrap="square" anchor="t">
-            <a:spAutoFit/>
-          </a:bodyPr>
-          <a:lstStyle/>
-          <a:p>
-            <a:pPr algn="ctr"/>
-            <a:r>
-              <a:rPr sz="1300" b="0">
-                <a:solidFill>
-                  <a:srgbClr val="57606A"/>
-                </a:solidFill>
-                <a:latin typeface="Segoe UI"/>
-              </a:rPr>
-              <a:t>Tool-agnostic parsers normalize STA · synthesis · power · area · UPF · SDC · congestion into one finding model.</a:t>
-            </a:r>
-          </a:p>
-        </p:txBody>
-      </p:sp>
-      <p:sp>
-        <p:nvSpPr>
-          <p:cNvPr id="7" name="Footer Placeholder 6">
-            <a:extLst>
-              <a:ext uri="{FF2B5EF4-FFF2-40B4-BE49-F238E27FC236}">
-                <a16:creationId xmlns:a16="http://schemas.microsoft.com/office/drawing/2014/main" id="{70C64B5F-0A6D-53D4-7F8E-684E630ACE64}"/>
-              </a:ext>
-            </a:extLst>
-          </p:cNvPr>
-          <p:cNvSpPr>
-            <a:spLocks noGrp="1"/>
-          </p:cNvSpPr>
-          <p:nvPr>
-            <p:ph type="ftr" sz="quarter" idx="11"/>
-          </p:nvPr>
-        </p:nvSpPr>
-        <p:spPr>
-          <a:xfrm>
-            <a:off x="548639" y="6476792"/>
-            <a:ext cx="2564987" cy="365125"/>
-          </a:xfrm>
-        </p:spPr>
-        <p:txBody>
-          <a:bodyPr/>
-          <a:lstStyle/>
-          <a:p>
-            <a:r>
-              <a:rPr lang="en-US" dirty="0" err="1"/>
-              <a:t>ClosureCopilot</a:t>
-            </a:r>
-            <a:r>
-              <a:rPr lang="en-US" dirty="0"/>
-              <a:t> · © 2026 Microsoft</a:t>
-            </a:r>
-          </a:p>
-        </p:txBody>
-      </p:sp>
-      <p:sp>
-        <p:nvSpPr>
-          <p:cNvPr id="8" name="Slide Number Placeholder 7">
-            <a:extLst>
-              <a:ext uri="{FF2B5EF4-FFF2-40B4-BE49-F238E27FC236}">
-                <a16:creationId xmlns:a16="http://schemas.microsoft.com/office/drawing/2014/main" id="{B32A82C9-93A7-3E31-8886-F5057491504C}"/>
-              </a:ext>
-            </a:extLst>
-          </p:cNvPr>
-          <p:cNvSpPr>
-            <a:spLocks noGrp="1"/>
-          </p:cNvSpPr>
-          <p:nvPr>
-            <p:ph type="sldNum" sz="quarter" idx="12"/>
-          </p:nvPr>
-        </p:nvSpPr>
-        <p:spPr/>
-        <p:txBody>
-          <a:bodyPr/>
-          <a:lstStyle/>
-          <a:p>
-            <a:fld id="{C1FF6DA9-008F-8B48-92A6-B652298478BF}" type="slidenum">
-              <a:rPr lang="en-US" smtClean="0"/>
-              <a:t>3</a:t>
-            </a:fld>
-            <a:endParaRPr lang="en-US"/>
-          </a:p>
-        </p:txBody>
-      </p:sp>
     </p:spTree>
   </p:cSld>
   <p:clrMapOvr>
@@ -4810,7 +4033,7 @@
 </file>
 
 <file path=ppt/slides/slide4.xml><?xml version="1.0" encoding="utf-8"?>
-<p:sld xmlns:a="http://schemas.openxmlformats.org/drawingml/2006/main" xmlns:r="http://schemas.openxmlformats.org/officeDocument/2006/relationships" xmlns:p="http://schemas.openxmlformats.org/presentationml/2006/main">
+<p:sld xmlns:a="http://schemas.openxmlformats.org/drawingml/2006/main" xmlns:p="http://schemas.openxmlformats.org/presentationml/2006/main" xmlns:r="http://schemas.openxmlformats.org/officeDocument/2006/relationships">
   <p:cSld>
     <p:spTree>
       <p:nvGrpSpPr>
@@ -4818,14 +4041,7 @@
         <p:cNvGrpSpPr/>
         <p:nvPr/>
       </p:nvGrpSpPr>
-      <p:grpSpPr>
-        <a:xfrm>
-          <a:off x="0" y="0"/>
-          <a:ext cx="0" cy="0"/>
-          <a:chOff x="0" y="0"/>
-          <a:chExt cx="0" cy="0"/>
-        </a:xfrm>
-      </p:grpSpPr>
+      <p:grpSpPr/>
       <p:sp>
         <p:nvSpPr>
           <p:cNvPr id="2" name="Rounded Rectangle 1"/>
@@ -4867,7 +4083,6 @@
           <a:lstStyle/>
           <a:p>
             <a:pPr algn="ctr"/>
-            <a:endParaRPr/>
           </a:p>
         </p:txBody>
       </p:sp>
@@ -4912,7 +4127,6 @@
           <a:lstStyle/>
           <a:p>
             <a:pPr algn="ctr"/>
-            <a:endParaRPr/>
           </a:p>
         </p:txBody>
       </p:sp>
@@ -4959,6 +4173,41 @@
         </p:nvSpPr>
         <p:spPr>
           <a:xfrm>
+            <a:off x="5486400" y="6473952"/>
+            <a:ext cx="6519672" cy="292608"/>
+          </a:xfrm>
+          <a:prstGeom prst="rect">
+            <a:avLst/>
+          </a:prstGeom>
+          <a:noFill/>
+        </p:spPr>
+        <p:txBody>
+          <a:bodyPr wrap="none">
+            <a:spAutoFit/>
+          </a:bodyPr>
+          <a:lstStyle/>
+          <a:p>
+            <a:pPr algn="r"/>
+            <a:r>
+              <a:rPr sz="900">
+                <a:solidFill>
+                  <a:srgbClr val="57606A"/>
+                </a:solidFill>
+                <a:latin typeface="Segoe UI"/>
+              </a:rPr>
+              <a:t>ClosureCopilot · Mayuresh Piske · © 2026 Microsoft</a:t>
+            </a:r>
+          </a:p>
+        </p:txBody>
+      </p:sp>
+      <p:sp>
+        <p:nvSpPr>
+          <p:cNvPr id="6" name="TextBox 5"/>
+          <p:cNvSpPr txBox="1"/>
+          <p:nvPr/>
+        </p:nvSpPr>
+        <p:spPr>
+          <a:xfrm>
             <a:off x="640080" y="1280160"/>
             <a:ext cx="10972800" cy="640080"/>
           </a:xfrm>
@@ -4988,7 +4237,7 @@
       </p:sp>
       <p:sp>
         <p:nvSpPr>
-          <p:cNvPr id="6" name="Rounded Rectangle 5"/>
+          <p:cNvPr id="7" name="Rounded Rectangle 6"/>
           <p:cNvSpPr/>
           <p:nvPr/>
         </p:nvSpPr>
@@ -5027,13 +4276,12 @@
           <a:lstStyle/>
           <a:p>
             <a:pPr algn="ctr"/>
-            <a:endParaRPr/>
-          </a:p>
-        </p:txBody>
-      </p:sp>
-      <p:sp>
-        <p:nvSpPr>
-          <p:cNvPr id="7" name="TextBox 6"/>
+          </a:p>
+        </p:txBody>
+      </p:sp>
+      <p:sp>
+        <p:nvSpPr>
+          <p:cNvPr id="8" name="TextBox 7"/>
           <p:cNvSpPr txBox="1"/>
           <p:nvPr/>
         </p:nvSpPr>
@@ -5104,7 +4352,7 @@
       </p:sp>
       <p:sp>
         <p:nvSpPr>
-          <p:cNvPr id="8" name="Rounded Rectangle 7"/>
+          <p:cNvPr id="9" name="Rounded Rectangle 8"/>
           <p:cNvSpPr/>
           <p:nvPr/>
         </p:nvSpPr>
@@ -5143,13 +4391,12 @@
           <a:lstStyle/>
           <a:p>
             <a:pPr algn="ctr"/>
-            <a:endParaRPr/>
-          </a:p>
-        </p:txBody>
-      </p:sp>
-      <p:sp>
-        <p:nvSpPr>
-          <p:cNvPr id="9" name="TextBox 8"/>
+          </a:p>
+        </p:txBody>
+      </p:sp>
+      <p:sp>
+        <p:nvSpPr>
+          <p:cNvPr id="10" name="TextBox 9"/>
           <p:cNvSpPr txBox="1"/>
           <p:nvPr/>
         </p:nvSpPr>
@@ -5220,7 +4467,7 @@
       </p:sp>
       <p:sp>
         <p:nvSpPr>
-          <p:cNvPr id="10" name="TextBox 9"/>
+          <p:cNvPr id="11" name="TextBox 10"/>
           <p:cNvSpPr txBox="1"/>
           <p:nvPr/>
         </p:nvSpPr>
@@ -5250,72 +4497,6 @@
               </a:rPr>
               <a:t>Every fix ships with a corrected, copy-paste snippet + a cross-domain PPA trade-off.</a:t>
             </a:r>
-          </a:p>
-        </p:txBody>
-      </p:sp>
-      <p:sp>
-        <p:nvSpPr>
-          <p:cNvPr id="11" name="Footer Placeholder 10">
-            <a:extLst>
-              <a:ext uri="{FF2B5EF4-FFF2-40B4-BE49-F238E27FC236}">
-                <a16:creationId xmlns:a16="http://schemas.microsoft.com/office/drawing/2014/main" id="{CDCA28F5-24ED-C6C5-22BD-9A93D513A93A}"/>
-              </a:ext>
-            </a:extLst>
-          </p:cNvPr>
-          <p:cNvSpPr>
-            <a:spLocks noGrp="1"/>
-          </p:cNvSpPr>
-          <p:nvPr>
-            <p:ph type="ftr" sz="quarter" idx="11"/>
-          </p:nvPr>
-        </p:nvSpPr>
-        <p:spPr>
-          <a:xfrm>
-            <a:off x="640080" y="6424613"/>
-            <a:ext cx="3639855" cy="365125"/>
-          </a:xfrm>
-        </p:spPr>
-        <p:txBody>
-          <a:bodyPr/>
-          <a:lstStyle/>
-          <a:p>
-            <a:r>
-              <a:rPr lang="en-US" dirty="0" err="1"/>
-              <a:t>ClosureCopilot</a:t>
-            </a:r>
-            <a:r>
-              <a:rPr lang="en-US" dirty="0"/>
-              <a:t> · Mayuresh Piske · © 2026 Microsoft</a:t>
-            </a:r>
-          </a:p>
-        </p:txBody>
-      </p:sp>
-      <p:sp>
-        <p:nvSpPr>
-          <p:cNvPr id="12" name="Slide Number Placeholder 11">
-            <a:extLst>
-              <a:ext uri="{FF2B5EF4-FFF2-40B4-BE49-F238E27FC236}">
-                <a16:creationId xmlns:a16="http://schemas.microsoft.com/office/drawing/2014/main" id="{F984C18B-1FB8-7174-D3B2-FEBB893456F6}"/>
-              </a:ext>
-            </a:extLst>
-          </p:cNvPr>
-          <p:cNvSpPr>
-            <a:spLocks noGrp="1"/>
-          </p:cNvSpPr>
-          <p:nvPr>
-            <p:ph type="sldNum" sz="quarter" idx="12"/>
-          </p:nvPr>
-        </p:nvSpPr>
-        <p:spPr/>
-        <p:txBody>
-          <a:bodyPr/>
-          <a:lstStyle/>
-          <a:p>
-            <a:fld id="{C1FF6DA9-008F-8B48-92A6-B652298478BF}" type="slidenum">
-              <a:rPr lang="en-US" smtClean="0"/>
-              <a:t>4</a:t>
-            </a:fld>
-            <a:endParaRPr lang="en-US"/>
           </a:p>
         </p:txBody>
       </p:sp>
@@ -5328,7 +4509,7 @@
 </file>
 
 <file path=ppt/slides/slide5.xml><?xml version="1.0" encoding="utf-8"?>
-<p:sld xmlns:a="http://schemas.openxmlformats.org/drawingml/2006/main" xmlns:r="http://schemas.openxmlformats.org/officeDocument/2006/relationships" xmlns:p="http://schemas.openxmlformats.org/presentationml/2006/main">
+<p:sld xmlns:a="http://schemas.openxmlformats.org/drawingml/2006/main" xmlns:p="http://schemas.openxmlformats.org/presentationml/2006/main" xmlns:r="http://schemas.openxmlformats.org/officeDocument/2006/relationships">
   <p:cSld>
     <p:spTree>
       <p:nvGrpSpPr>
@@ -5336,14 +4517,7 @@
         <p:cNvGrpSpPr/>
         <p:nvPr/>
       </p:nvGrpSpPr>
-      <p:grpSpPr>
-        <a:xfrm>
-          <a:off x="0" y="0"/>
-          <a:ext cx="0" cy="0"/>
-          <a:chOff x="0" y="0"/>
-          <a:chExt cx="0" cy="0"/>
-        </a:xfrm>
-      </p:grpSpPr>
+      <p:grpSpPr/>
       <p:sp>
         <p:nvSpPr>
           <p:cNvPr id="2" name="Rounded Rectangle 1"/>
@@ -5385,7 +4559,6 @@
           <a:lstStyle/>
           <a:p>
             <a:pPr algn="ctr"/>
-            <a:endParaRPr/>
           </a:p>
         </p:txBody>
       </p:sp>
@@ -5430,7 +4603,6 @@
           <a:lstStyle/>
           <a:p>
             <a:pPr algn="ctr"/>
-            <a:endParaRPr/>
           </a:p>
         </p:txBody>
       </p:sp>
@@ -5471,7 +4643,42 @@
       </p:sp>
       <p:sp>
         <p:nvSpPr>
-          <p:cNvPr id="5" name="Rounded Rectangle 4"/>
+          <p:cNvPr id="5" name="TextBox 4"/>
+          <p:cNvSpPr txBox="1"/>
+          <p:nvPr/>
+        </p:nvSpPr>
+        <p:spPr>
+          <a:xfrm>
+            <a:off x="5486400" y="6473952"/>
+            <a:ext cx="6519672" cy="292608"/>
+          </a:xfrm>
+          <a:prstGeom prst="rect">
+            <a:avLst/>
+          </a:prstGeom>
+          <a:noFill/>
+        </p:spPr>
+        <p:txBody>
+          <a:bodyPr wrap="none">
+            <a:spAutoFit/>
+          </a:bodyPr>
+          <a:lstStyle/>
+          <a:p>
+            <a:pPr algn="r"/>
+            <a:r>
+              <a:rPr sz="900">
+                <a:solidFill>
+                  <a:srgbClr val="57606A"/>
+                </a:solidFill>
+                <a:latin typeface="Segoe UI"/>
+              </a:rPr>
+              <a:t>ClosureCopilot · Mayuresh Piske · © 2026 Microsoft</a:t>
+            </a:r>
+          </a:p>
+        </p:txBody>
+      </p:sp>
+      <p:sp>
+        <p:nvSpPr>
+          <p:cNvPr id="6" name="Rounded Rectangle 5"/>
           <p:cNvSpPr/>
           <p:nvPr/>
         </p:nvSpPr>
@@ -5510,13 +4717,12 @@
           <a:lstStyle/>
           <a:p>
             <a:pPr algn="ctr"/>
-            <a:endParaRPr/>
-          </a:p>
-        </p:txBody>
-      </p:sp>
-      <p:sp>
-        <p:nvSpPr>
-          <p:cNvPr id="6" name="Rounded Rectangle 5"/>
+          </a:p>
+        </p:txBody>
+      </p:sp>
+      <p:sp>
+        <p:nvSpPr>
+          <p:cNvPr id="7" name="Rounded Rectangle 6"/>
           <p:cNvSpPr/>
           <p:nvPr/>
         </p:nvSpPr>
@@ -5555,13 +4761,12 @@
           <a:lstStyle/>
           <a:p>
             <a:pPr algn="ctr"/>
-            <a:endParaRPr/>
-          </a:p>
-        </p:txBody>
-      </p:sp>
-      <p:sp>
-        <p:nvSpPr>
-          <p:cNvPr id="7" name="TextBox 6"/>
+          </a:p>
+        </p:txBody>
+      </p:sp>
+      <p:sp>
+        <p:nvSpPr>
+          <p:cNvPr id="8" name="TextBox 7"/>
           <p:cNvSpPr txBox="1"/>
           <p:nvPr/>
         </p:nvSpPr>
@@ -5596,7 +4801,7 @@
       </p:sp>
       <p:sp>
         <p:nvSpPr>
-          <p:cNvPr id="8" name="TextBox 7"/>
+          <p:cNvPr id="9" name="TextBox 8"/>
           <p:cNvSpPr txBox="1"/>
           <p:nvPr/>
         </p:nvSpPr>
@@ -5631,7 +4836,7 @@
       </p:sp>
       <p:sp>
         <p:nvSpPr>
-          <p:cNvPr id="9" name="Rounded Rectangle 8"/>
+          <p:cNvPr id="10" name="Rounded Rectangle 9"/>
           <p:cNvSpPr/>
           <p:nvPr/>
         </p:nvSpPr>
@@ -5670,13 +4875,12 @@
           <a:lstStyle/>
           <a:p>
             <a:pPr algn="ctr"/>
-            <a:endParaRPr/>
-          </a:p>
-        </p:txBody>
-      </p:sp>
-      <p:sp>
-        <p:nvSpPr>
-          <p:cNvPr id="10" name="Rounded Rectangle 9"/>
+          </a:p>
+        </p:txBody>
+      </p:sp>
+      <p:sp>
+        <p:nvSpPr>
+          <p:cNvPr id="11" name="Rounded Rectangle 10"/>
           <p:cNvSpPr/>
           <p:nvPr/>
         </p:nvSpPr>
@@ -5715,13 +4919,12 @@
           <a:lstStyle/>
           <a:p>
             <a:pPr algn="ctr"/>
-            <a:endParaRPr/>
-          </a:p>
-        </p:txBody>
-      </p:sp>
-      <p:sp>
-        <p:nvSpPr>
-          <p:cNvPr id="11" name="TextBox 10"/>
+          </a:p>
+        </p:txBody>
+      </p:sp>
+      <p:sp>
+        <p:nvSpPr>
+          <p:cNvPr id="12" name="TextBox 11"/>
           <p:cNvSpPr txBox="1"/>
           <p:nvPr/>
         </p:nvSpPr>
@@ -5756,7 +4959,7 @@
       </p:sp>
       <p:sp>
         <p:nvSpPr>
-          <p:cNvPr id="12" name="TextBox 11"/>
+          <p:cNvPr id="13" name="TextBox 12"/>
           <p:cNvSpPr txBox="1"/>
           <p:nvPr/>
         </p:nvSpPr>
@@ -5791,7 +4994,7 @@
       </p:sp>
       <p:sp>
         <p:nvSpPr>
-          <p:cNvPr id="13" name="Rounded Rectangle 12"/>
+          <p:cNvPr id="14" name="Rounded Rectangle 13"/>
           <p:cNvSpPr/>
           <p:nvPr/>
         </p:nvSpPr>
@@ -5830,13 +5033,12 @@
           <a:lstStyle/>
           <a:p>
             <a:pPr algn="ctr"/>
-            <a:endParaRPr/>
-          </a:p>
-        </p:txBody>
-      </p:sp>
-      <p:sp>
-        <p:nvSpPr>
-          <p:cNvPr id="14" name="Rounded Rectangle 13"/>
+          </a:p>
+        </p:txBody>
+      </p:sp>
+      <p:sp>
+        <p:nvSpPr>
+          <p:cNvPr id="15" name="Rounded Rectangle 14"/>
           <p:cNvSpPr/>
           <p:nvPr/>
         </p:nvSpPr>
@@ -5875,13 +5077,12 @@
           <a:lstStyle/>
           <a:p>
             <a:pPr algn="ctr"/>
-            <a:endParaRPr/>
-          </a:p>
-        </p:txBody>
-      </p:sp>
-      <p:sp>
-        <p:nvSpPr>
-          <p:cNvPr id="15" name="TextBox 14"/>
+          </a:p>
+        </p:txBody>
+      </p:sp>
+      <p:sp>
+        <p:nvSpPr>
+          <p:cNvPr id="16" name="TextBox 15"/>
           <p:cNvSpPr txBox="1"/>
           <p:nvPr/>
         </p:nvSpPr>
@@ -5916,7 +5117,7 @@
       </p:sp>
       <p:sp>
         <p:nvSpPr>
-          <p:cNvPr id="16" name="TextBox 15"/>
+          <p:cNvPr id="17" name="TextBox 16"/>
           <p:cNvSpPr txBox="1"/>
           <p:nvPr/>
         </p:nvSpPr>
@@ -5951,7 +5152,7 @@
       </p:sp>
       <p:sp>
         <p:nvSpPr>
-          <p:cNvPr id="17" name="Rounded Rectangle 16"/>
+          <p:cNvPr id="18" name="Rounded Rectangle 17"/>
           <p:cNvSpPr/>
           <p:nvPr/>
         </p:nvSpPr>
@@ -5990,13 +5191,12 @@
           <a:lstStyle/>
           <a:p>
             <a:pPr algn="ctr"/>
-            <a:endParaRPr/>
-          </a:p>
-        </p:txBody>
-      </p:sp>
-      <p:sp>
-        <p:nvSpPr>
-          <p:cNvPr id="18" name="Rounded Rectangle 17"/>
+          </a:p>
+        </p:txBody>
+      </p:sp>
+      <p:sp>
+        <p:nvSpPr>
+          <p:cNvPr id="19" name="Rounded Rectangle 18"/>
           <p:cNvSpPr/>
           <p:nvPr/>
         </p:nvSpPr>
@@ -6035,13 +5235,12 @@
           <a:lstStyle/>
           <a:p>
             <a:pPr algn="ctr"/>
-            <a:endParaRPr/>
-          </a:p>
-        </p:txBody>
-      </p:sp>
-      <p:sp>
-        <p:nvSpPr>
-          <p:cNvPr id="19" name="TextBox 18"/>
+          </a:p>
+        </p:txBody>
+      </p:sp>
+      <p:sp>
+        <p:nvSpPr>
+          <p:cNvPr id="20" name="TextBox 19"/>
           <p:cNvSpPr txBox="1"/>
           <p:nvPr/>
         </p:nvSpPr>
@@ -6076,7 +5275,7 @@
       </p:sp>
       <p:sp>
         <p:nvSpPr>
-          <p:cNvPr id="20" name="TextBox 19"/>
+          <p:cNvPr id="21" name="TextBox 20"/>
           <p:cNvSpPr txBox="1"/>
           <p:nvPr/>
         </p:nvSpPr>
@@ -6111,7 +5310,7 @@
       </p:sp>
       <p:sp>
         <p:nvSpPr>
-          <p:cNvPr id="21" name="Rounded Rectangle 20"/>
+          <p:cNvPr id="22" name="Rounded Rectangle 21"/>
           <p:cNvSpPr/>
           <p:nvPr/>
         </p:nvSpPr>
@@ -6150,13 +5349,12 @@
           <a:lstStyle/>
           <a:p>
             <a:pPr algn="ctr"/>
-            <a:endParaRPr/>
-          </a:p>
-        </p:txBody>
-      </p:sp>
-      <p:sp>
-        <p:nvSpPr>
-          <p:cNvPr id="22" name="Rounded Rectangle 21"/>
+          </a:p>
+        </p:txBody>
+      </p:sp>
+      <p:sp>
+        <p:nvSpPr>
+          <p:cNvPr id="23" name="Rounded Rectangle 22"/>
           <p:cNvSpPr/>
           <p:nvPr/>
         </p:nvSpPr>
@@ -6195,13 +5393,12 @@
           <a:lstStyle/>
           <a:p>
             <a:pPr algn="ctr"/>
-            <a:endParaRPr/>
-          </a:p>
-        </p:txBody>
-      </p:sp>
-      <p:sp>
-        <p:nvSpPr>
-          <p:cNvPr id="23" name="TextBox 22"/>
+          </a:p>
+        </p:txBody>
+      </p:sp>
+      <p:sp>
+        <p:nvSpPr>
+          <p:cNvPr id="24" name="TextBox 23"/>
           <p:cNvSpPr txBox="1"/>
           <p:nvPr/>
         </p:nvSpPr>
@@ -6236,7 +5433,7 @@
       </p:sp>
       <p:sp>
         <p:nvSpPr>
-          <p:cNvPr id="24" name="TextBox 23"/>
+          <p:cNvPr id="25" name="TextBox 24"/>
           <p:cNvSpPr txBox="1"/>
           <p:nvPr/>
         </p:nvSpPr>
@@ -6266,72 +5463,6 @@
               </a:rPr>
               <a:t>Turns P&amp;R congestion into concrete RTL restructuring hints.</a:t>
             </a:r>
-          </a:p>
-        </p:txBody>
-      </p:sp>
-      <p:sp>
-        <p:nvSpPr>
-          <p:cNvPr id="25" name="Footer Placeholder 24">
-            <a:extLst>
-              <a:ext uri="{FF2B5EF4-FFF2-40B4-BE49-F238E27FC236}">
-                <a16:creationId xmlns:a16="http://schemas.microsoft.com/office/drawing/2014/main" id="{7E55F50A-2D07-CDDF-D02C-81095889BAF9}"/>
-              </a:ext>
-            </a:extLst>
-          </p:cNvPr>
-          <p:cNvSpPr>
-            <a:spLocks noGrp="1"/>
-          </p:cNvSpPr>
-          <p:nvPr>
-            <p:ph type="ftr" sz="quarter" idx="11"/>
-          </p:nvPr>
-        </p:nvSpPr>
-        <p:spPr>
-          <a:xfrm>
-            <a:off x="722376" y="6492875"/>
-            <a:ext cx="3483279" cy="365125"/>
-          </a:xfrm>
-        </p:spPr>
-        <p:txBody>
-          <a:bodyPr/>
-          <a:lstStyle/>
-          <a:p>
-            <a:r>
-              <a:rPr lang="en-US" dirty="0" err="1"/>
-              <a:t>ClosureCopilot</a:t>
-            </a:r>
-            <a:r>
-              <a:rPr lang="en-US" dirty="0"/>
-              <a:t> · Mayuresh Piske · © 2026 Microsoft</a:t>
-            </a:r>
-          </a:p>
-        </p:txBody>
-      </p:sp>
-      <p:sp>
-        <p:nvSpPr>
-          <p:cNvPr id="26" name="Slide Number Placeholder 25">
-            <a:extLst>
-              <a:ext uri="{FF2B5EF4-FFF2-40B4-BE49-F238E27FC236}">
-                <a16:creationId xmlns:a16="http://schemas.microsoft.com/office/drawing/2014/main" id="{97A18FC6-935B-46D4-22CB-3431383DA313}"/>
-              </a:ext>
-            </a:extLst>
-          </p:cNvPr>
-          <p:cNvSpPr>
-            <a:spLocks noGrp="1"/>
-          </p:cNvSpPr>
-          <p:nvPr>
-            <p:ph type="sldNum" sz="quarter" idx="12"/>
-          </p:nvPr>
-        </p:nvSpPr>
-        <p:spPr/>
-        <p:txBody>
-          <a:bodyPr/>
-          <a:lstStyle/>
-          <a:p>
-            <a:fld id="{C1FF6DA9-008F-8B48-92A6-B652298478BF}" type="slidenum">
-              <a:rPr lang="en-US" smtClean="0"/>
-              <a:t>5</a:t>
-            </a:fld>
-            <a:endParaRPr lang="en-US"/>
           </a:p>
         </p:txBody>
       </p:sp>
@@ -6344,7 +5475,7 @@
 </file>
 
 <file path=ppt/slides/slide6.xml><?xml version="1.0" encoding="utf-8"?>
-<p:sld xmlns:a="http://schemas.openxmlformats.org/drawingml/2006/main" xmlns:r="http://schemas.openxmlformats.org/officeDocument/2006/relationships" xmlns:p="http://schemas.openxmlformats.org/presentationml/2006/main">
+<p:sld xmlns:a="http://schemas.openxmlformats.org/drawingml/2006/main" xmlns:p="http://schemas.openxmlformats.org/presentationml/2006/main" xmlns:r="http://schemas.openxmlformats.org/officeDocument/2006/relationships">
   <p:cSld>
     <p:spTree>
       <p:nvGrpSpPr>
@@ -6352,14 +5483,7 @@
         <p:cNvGrpSpPr/>
         <p:nvPr/>
       </p:nvGrpSpPr>
-      <p:grpSpPr>
-        <a:xfrm>
-          <a:off x="0" y="0"/>
-          <a:ext cx="0" cy="0"/>
-          <a:chOff x="0" y="0"/>
-          <a:chExt cx="0" cy="0"/>
-        </a:xfrm>
-      </p:grpSpPr>
+      <p:grpSpPr/>
       <p:sp>
         <p:nvSpPr>
           <p:cNvPr id="2" name="Rounded Rectangle 1"/>
@@ -6401,7 +5525,6 @@
           <a:lstStyle/>
           <a:p>
             <a:pPr algn="ctr"/>
-            <a:endParaRPr/>
           </a:p>
         </p:txBody>
       </p:sp>
@@ -6446,7 +5569,6 @@
           <a:lstStyle/>
           <a:p>
             <a:pPr algn="ctr"/>
-            <a:endParaRPr/>
           </a:p>
         </p:txBody>
       </p:sp>
@@ -6487,7 +5609,42 @@
       </p:sp>
       <p:sp>
         <p:nvSpPr>
-          <p:cNvPr id="5" name="Rounded Rectangle 4"/>
+          <p:cNvPr id="5" name="TextBox 4"/>
+          <p:cNvSpPr txBox="1"/>
+          <p:nvPr/>
+        </p:nvSpPr>
+        <p:spPr>
+          <a:xfrm>
+            <a:off x="5486400" y="6473952"/>
+            <a:ext cx="6519672" cy="292608"/>
+          </a:xfrm>
+          <a:prstGeom prst="rect">
+            <a:avLst/>
+          </a:prstGeom>
+          <a:noFill/>
+        </p:spPr>
+        <p:txBody>
+          <a:bodyPr wrap="none">
+            <a:spAutoFit/>
+          </a:bodyPr>
+          <a:lstStyle/>
+          <a:p>
+            <a:pPr algn="r"/>
+            <a:r>
+              <a:rPr sz="900">
+                <a:solidFill>
+                  <a:srgbClr val="57606A"/>
+                </a:solidFill>
+                <a:latin typeface="Segoe UI"/>
+              </a:rPr>
+              <a:t>ClosureCopilot · Mayuresh Piske · © 2026 Microsoft</a:t>
+            </a:r>
+          </a:p>
+        </p:txBody>
+      </p:sp>
+      <p:sp>
+        <p:nvSpPr>
+          <p:cNvPr id="6" name="Rounded Rectangle 5"/>
           <p:cNvSpPr/>
           <p:nvPr/>
         </p:nvSpPr>
@@ -6526,13 +5683,12 @@
           <a:lstStyle/>
           <a:p>
             <a:pPr algn="ctr"/>
-            <a:endParaRPr/>
-          </a:p>
-        </p:txBody>
-      </p:sp>
-      <p:sp>
-        <p:nvSpPr>
-          <p:cNvPr id="6" name="TextBox 5"/>
+          </a:p>
+        </p:txBody>
+      </p:sp>
+      <p:sp>
+        <p:nvSpPr>
+          <p:cNvPr id="7" name="TextBox 6"/>
           <p:cNvSpPr txBox="1"/>
           <p:nvPr/>
         </p:nvSpPr>
@@ -6627,7 +5783,7 @@
       </p:sp>
       <p:sp>
         <p:nvSpPr>
-          <p:cNvPr id="7" name="Rounded Rectangle 6"/>
+          <p:cNvPr id="8" name="Rounded Rectangle 7"/>
           <p:cNvSpPr/>
           <p:nvPr/>
         </p:nvSpPr>
@@ -6666,13 +5822,12 @@
           <a:lstStyle/>
           <a:p>
             <a:pPr algn="ctr"/>
-            <a:endParaRPr/>
-          </a:p>
-        </p:txBody>
-      </p:sp>
-      <p:sp>
-        <p:nvSpPr>
-          <p:cNvPr id="8" name="TextBox 7"/>
+          </a:p>
+        </p:txBody>
+      </p:sp>
+      <p:sp>
+        <p:nvSpPr>
+          <p:cNvPr id="9" name="TextBox 8"/>
           <p:cNvSpPr txBox="1"/>
           <p:nvPr/>
         </p:nvSpPr>
@@ -6762,72 +5917,6 @@
               </a:rPr>
               <a:t>Runs reliably with or without credentials — the demo never breaks.</a:t>
             </a:r>
-          </a:p>
-        </p:txBody>
-      </p:sp>
-      <p:sp>
-        <p:nvSpPr>
-          <p:cNvPr id="9" name="Footer Placeholder 8">
-            <a:extLst>
-              <a:ext uri="{FF2B5EF4-FFF2-40B4-BE49-F238E27FC236}">
-                <a16:creationId xmlns:a16="http://schemas.microsoft.com/office/drawing/2014/main" id="{FB081541-3697-02EB-CA09-947B1D5C7B05}"/>
-              </a:ext>
-            </a:extLst>
-          </p:cNvPr>
-          <p:cNvSpPr>
-            <a:spLocks noGrp="1"/>
-          </p:cNvSpPr>
-          <p:nvPr>
-            <p:ph type="ftr" sz="quarter" idx="11"/>
-          </p:nvPr>
-        </p:nvSpPr>
-        <p:spPr>
-          <a:xfrm>
-            <a:off x="726509" y="6463461"/>
-            <a:ext cx="3721274" cy="365125"/>
-          </a:xfrm>
-        </p:spPr>
-        <p:txBody>
-          <a:bodyPr/>
-          <a:lstStyle/>
-          <a:p>
-            <a:r>
-              <a:rPr lang="en-US" dirty="0" err="1"/>
-              <a:t>ClosureCopilot</a:t>
-            </a:r>
-            <a:r>
-              <a:rPr lang="en-US" dirty="0"/>
-              <a:t> · Mayuresh Piske · © 2026 Microsoft</a:t>
-            </a:r>
-          </a:p>
-        </p:txBody>
-      </p:sp>
-      <p:sp>
-        <p:nvSpPr>
-          <p:cNvPr id="10" name="Slide Number Placeholder 9">
-            <a:extLst>
-              <a:ext uri="{FF2B5EF4-FFF2-40B4-BE49-F238E27FC236}">
-                <a16:creationId xmlns:a16="http://schemas.microsoft.com/office/drawing/2014/main" id="{3D4ED3BB-8D92-13D8-AB29-2BD15A55CE06}"/>
-              </a:ext>
-            </a:extLst>
-          </p:cNvPr>
-          <p:cNvSpPr>
-            <a:spLocks noGrp="1"/>
-          </p:cNvSpPr>
-          <p:nvPr>
-            <p:ph type="sldNum" sz="quarter" idx="12"/>
-          </p:nvPr>
-        </p:nvSpPr>
-        <p:spPr/>
-        <p:txBody>
-          <a:bodyPr/>
-          <a:lstStyle/>
-          <a:p>
-            <a:fld id="{C1FF6DA9-008F-8B48-92A6-B652298478BF}" type="slidenum">
-              <a:rPr lang="en-US" smtClean="0"/>
-              <a:t>6</a:t>
-            </a:fld>
-            <a:endParaRPr lang="en-US"/>
           </a:p>
         </p:txBody>
       </p:sp>
@@ -6840,7 +5929,7 @@
 </file>
 
 <file path=ppt/slides/slide7.xml><?xml version="1.0" encoding="utf-8"?>
-<p:sld xmlns:a="http://schemas.openxmlformats.org/drawingml/2006/main" xmlns:r="http://schemas.openxmlformats.org/officeDocument/2006/relationships" xmlns:p="http://schemas.openxmlformats.org/presentationml/2006/main">
+<p:sld xmlns:a="http://schemas.openxmlformats.org/drawingml/2006/main" xmlns:p="http://schemas.openxmlformats.org/presentationml/2006/main" xmlns:r="http://schemas.openxmlformats.org/officeDocument/2006/relationships">
   <p:cSld>
     <p:spTree>
       <p:nvGrpSpPr>
@@ -6848,14 +5937,7 @@
         <p:cNvGrpSpPr/>
         <p:nvPr/>
       </p:nvGrpSpPr>
-      <p:grpSpPr>
-        <a:xfrm>
-          <a:off x="0" y="0"/>
-          <a:ext cx="0" cy="0"/>
-          <a:chOff x="0" y="0"/>
-          <a:chExt cx="0" cy="0"/>
-        </a:xfrm>
-      </p:grpSpPr>
+      <p:grpSpPr/>
       <p:sp>
         <p:nvSpPr>
           <p:cNvPr id="2" name="Rounded Rectangle 1"/>
@@ -6897,7 +5979,6 @@
           <a:lstStyle/>
           <a:p>
             <a:pPr algn="ctr"/>
-            <a:endParaRPr/>
           </a:p>
         </p:txBody>
       </p:sp>
@@ -6942,7 +6023,6 @@
           <a:lstStyle/>
           <a:p>
             <a:pPr algn="ctr"/>
-            <a:endParaRPr/>
           </a:p>
         </p:txBody>
       </p:sp>
@@ -6983,7 +6063,42 @@
       </p:sp>
       <p:sp>
         <p:nvSpPr>
-          <p:cNvPr id="5" name="Rounded Rectangle 4"/>
+          <p:cNvPr id="5" name="TextBox 4"/>
+          <p:cNvSpPr txBox="1"/>
+          <p:nvPr/>
+        </p:nvSpPr>
+        <p:spPr>
+          <a:xfrm>
+            <a:off x="5486400" y="6473952"/>
+            <a:ext cx="6519672" cy="292608"/>
+          </a:xfrm>
+          <a:prstGeom prst="rect">
+            <a:avLst/>
+          </a:prstGeom>
+          <a:noFill/>
+        </p:spPr>
+        <p:txBody>
+          <a:bodyPr wrap="none">
+            <a:spAutoFit/>
+          </a:bodyPr>
+          <a:lstStyle/>
+          <a:p>
+            <a:pPr algn="r"/>
+            <a:r>
+              <a:rPr sz="900">
+                <a:solidFill>
+                  <a:srgbClr val="57606A"/>
+                </a:solidFill>
+                <a:latin typeface="Segoe UI"/>
+              </a:rPr>
+              <a:t>ClosureCopilot · Mayuresh Piske · © 2026 Microsoft</a:t>
+            </a:r>
+          </a:p>
+        </p:txBody>
+      </p:sp>
+      <p:sp>
+        <p:nvSpPr>
+          <p:cNvPr id="6" name="Rounded Rectangle 5"/>
           <p:cNvSpPr/>
           <p:nvPr/>
         </p:nvSpPr>
@@ -7022,13 +6137,12 @@
           <a:lstStyle/>
           <a:p>
             <a:pPr algn="ctr"/>
-            <a:endParaRPr/>
-          </a:p>
-        </p:txBody>
-      </p:sp>
-      <p:sp>
-        <p:nvSpPr>
-          <p:cNvPr id="6" name="TextBox 5"/>
+          </a:p>
+        </p:txBody>
+      </p:sp>
+      <p:sp>
+        <p:nvSpPr>
+          <p:cNvPr id="7" name="TextBox 6"/>
           <p:cNvSpPr txBox="1"/>
           <p:nvPr/>
         </p:nvSpPr>
@@ -7087,7 +6201,7 @@
       </p:sp>
       <p:sp>
         <p:nvSpPr>
-          <p:cNvPr id="7" name="Rounded Rectangle 6"/>
+          <p:cNvPr id="8" name="Rounded Rectangle 7"/>
           <p:cNvSpPr/>
           <p:nvPr/>
         </p:nvSpPr>
@@ -7126,13 +6240,12 @@
           <a:lstStyle/>
           <a:p>
             <a:pPr algn="ctr"/>
-            <a:endParaRPr/>
-          </a:p>
-        </p:txBody>
-      </p:sp>
-      <p:sp>
-        <p:nvSpPr>
-          <p:cNvPr id="8" name="TextBox 7"/>
+          </a:p>
+        </p:txBody>
+      </p:sp>
+      <p:sp>
+        <p:nvSpPr>
+          <p:cNvPr id="9" name="TextBox 8"/>
           <p:cNvSpPr txBox="1"/>
           <p:nvPr/>
         </p:nvSpPr>
@@ -7198,72 +6311,6 @@
               </a:rPr>
               <a:t>Catches unrealized intent and lost constraints before the next costly backend run.</a:t>
             </a:r>
-          </a:p>
-        </p:txBody>
-      </p:sp>
-      <p:sp>
-        <p:nvSpPr>
-          <p:cNvPr id="9" name="Footer Placeholder 8">
-            <a:extLst>
-              <a:ext uri="{FF2B5EF4-FFF2-40B4-BE49-F238E27FC236}">
-                <a16:creationId xmlns:a16="http://schemas.microsoft.com/office/drawing/2014/main" id="{3F30E14D-839F-E276-DF2D-B2EF76D28596}"/>
-              </a:ext>
-            </a:extLst>
-          </p:cNvPr>
-          <p:cNvSpPr>
-            <a:spLocks noGrp="1"/>
-          </p:cNvSpPr>
-          <p:nvPr>
-            <p:ph type="ftr" sz="quarter" idx="11"/>
-          </p:nvPr>
-        </p:nvSpPr>
-        <p:spPr>
-          <a:xfrm>
-            <a:off x="640080" y="6440601"/>
-            <a:ext cx="3821482" cy="365125"/>
-          </a:xfrm>
-        </p:spPr>
-        <p:txBody>
-          <a:bodyPr/>
-          <a:lstStyle/>
-          <a:p>
-            <a:r>
-              <a:rPr lang="en-US" dirty="0" err="1"/>
-              <a:t>ClosureCopilot</a:t>
-            </a:r>
-            <a:r>
-              <a:rPr lang="en-US" dirty="0"/>
-              <a:t> · Mayuresh Piske · © 2026 Microsoft</a:t>
-            </a:r>
-          </a:p>
-        </p:txBody>
-      </p:sp>
-      <p:sp>
-        <p:nvSpPr>
-          <p:cNvPr id="10" name="Slide Number Placeholder 9">
-            <a:extLst>
-              <a:ext uri="{FF2B5EF4-FFF2-40B4-BE49-F238E27FC236}">
-                <a16:creationId xmlns:a16="http://schemas.microsoft.com/office/drawing/2014/main" id="{6BCC1590-4137-BEAB-B5DE-8490219A9C3C}"/>
-              </a:ext>
-            </a:extLst>
-          </p:cNvPr>
-          <p:cNvSpPr>
-            <a:spLocks noGrp="1"/>
-          </p:cNvSpPr>
-          <p:nvPr>
-            <p:ph type="sldNum" sz="quarter" idx="12"/>
-          </p:nvPr>
-        </p:nvSpPr>
-        <p:spPr/>
-        <p:txBody>
-          <a:bodyPr/>
-          <a:lstStyle/>
-          <a:p>
-            <a:fld id="{C1FF6DA9-008F-8B48-92A6-B652298478BF}" type="slidenum">
-              <a:rPr lang="en-US" smtClean="0"/>
-              <a:t>7</a:t>
-            </a:fld>
-            <a:endParaRPr lang="en-US"/>
           </a:p>
         </p:txBody>
       </p:sp>
@@ -7276,7 +6323,7 @@
 </file>
 
 <file path=ppt/slides/slide8.xml><?xml version="1.0" encoding="utf-8"?>
-<p:sld xmlns:a="http://schemas.openxmlformats.org/drawingml/2006/main" xmlns:r="http://schemas.openxmlformats.org/officeDocument/2006/relationships" xmlns:p="http://schemas.openxmlformats.org/presentationml/2006/main">
+<p:sld xmlns:a="http://schemas.openxmlformats.org/drawingml/2006/main" xmlns:p="http://schemas.openxmlformats.org/presentationml/2006/main" xmlns:r="http://schemas.openxmlformats.org/officeDocument/2006/relationships">
   <p:cSld>
     <p:spTree>
       <p:nvGrpSpPr>
@@ -7284,14 +6331,7 @@
         <p:cNvGrpSpPr/>
         <p:nvPr/>
       </p:nvGrpSpPr>
-      <p:grpSpPr>
-        <a:xfrm>
-          <a:off x="0" y="0"/>
-          <a:ext cx="0" cy="0"/>
-          <a:chOff x="0" y="0"/>
-          <a:chExt cx="0" cy="0"/>
-        </a:xfrm>
-      </p:grpSpPr>
+      <p:grpSpPr/>
       <p:sp>
         <p:nvSpPr>
           <p:cNvPr id="2" name="Rounded Rectangle 1"/>
@@ -7333,7 +6373,6 @@
           <a:lstStyle/>
           <a:p>
             <a:pPr algn="ctr"/>
-            <a:endParaRPr/>
           </a:p>
         </p:txBody>
       </p:sp>
@@ -7439,72 +6478,6 @@
               </a:rPr>
               <a:t>github.com/mayureshpiske19/ClosureCopilot</a:t>
             </a:r>
-          </a:p>
-        </p:txBody>
-      </p:sp>
-      <p:sp>
-        <p:nvSpPr>
-          <p:cNvPr id="6" name="Footer Placeholder 5">
-            <a:extLst>
-              <a:ext uri="{FF2B5EF4-FFF2-40B4-BE49-F238E27FC236}">
-                <a16:creationId xmlns:a16="http://schemas.microsoft.com/office/drawing/2014/main" id="{C4C2C17A-6560-086A-57BE-9E6D36D66ACA}"/>
-              </a:ext>
-            </a:extLst>
-          </p:cNvPr>
-          <p:cNvSpPr>
-            <a:spLocks noGrp="1"/>
-          </p:cNvSpPr>
-          <p:nvPr>
-            <p:ph type="ftr" sz="quarter" idx="11"/>
-          </p:nvPr>
-        </p:nvSpPr>
-        <p:spPr>
-          <a:xfrm>
-            <a:off x="822960" y="6356350"/>
-            <a:ext cx="4072003" cy="365125"/>
-          </a:xfrm>
-        </p:spPr>
-        <p:txBody>
-          <a:bodyPr/>
-          <a:lstStyle/>
-          <a:p>
-            <a:r>
-              <a:rPr lang="en-US" dirty="0" err="1"/>
-              <a:t>ClosureCopilot</a:t>
-            </a:r>
-            <a:r>
-              <a:rPr lang="en-US" dirty="0"/>
-              <a:t> · Mayuresh Piske · © 2026 Microsoft</a:t>
-            </a:r>
-          </a:p>
-        </p:txBody>
-      </p:sp>
-      <p:sp>
-        <p:nvSpPr>
-          <p:cNvPr id="7" name="Slide Number Placeholder 6">
-            <a:extLst>
-              <a:ext uri="{FF2B5EF4-FFF2-40B4-BE49-F238E27FC236}">
-                <a16:creationId xmlns:a16="http://schemas.microsoft.com/office/drawing/2014/main" id="{4B62701B-EC8F-97EC-DB7F-0A1AFE4EFE25}"/>
-              </a:ext>
-            </a:extLst>
-          </p:cNvPr>
-          <p:cNvSpPr>
-            <a:spLocks noGrp="1"/>
-          </p:cNvSpPr>
-          <p:nvPr>
-            <p:ph type="sldNum" sz="quarter" idx="12"/>
-          </p:nvPr>
-        </p:nvSpPr>
-        <p:spPr/>
-        <p:txBody>
-          <a:bodyPr/>
-          <a:lstStyle/>
-          <a:p>
-            <a:fld id="{C1FF6DA9-008F-8B48-92A6-B652298478BF}" type="slidenum">
-              <a:rPr lang="en-US" smtClean="0"/>
-              <a:t>8</a:t>
-            </a:fld>
-            <a:endParaRPr lang="en-US"/>
           </a:p>
         </p:txBody>
       </p:sp>
@@ -7834,325 +6807,4 @@
   </a:objectDefaults>
   <a:extraClrSchemeLst/>
 </a:theme>
-</file>
-
-<file path=ppt/theme/theme2.xml><?xml version="1.0" encoding="utf-8"?>
-<a:theme xmlns:a="http://schemas.openxmlformats.org/drawingml/2006/main" name="Office Theme">
-  <a:themeElements>
-    <a:clrScheme name="Office">
-      <a:dk1>
-        <a:sysClr val="windowText" lastClr="000000"/>
-      </a:dk1>
-      <a:lt1>
-        <a:sysClr val="window" lastClr="FFFFFF"/>
-      </a:lt1>
-      <a:dk2>
-        <a:srgbClr val="0E2841"/>
-      </a:dk2>
-      <a:lt2>
-        <a:srgbClr val="E8E8E8"/>
-      </a:lt2>
-      <a:accent1>
-        <a:srgbClr val="156082"/>
-      </a:accent1>
-      <a:accent2>
-        <a:srgbClr val="E97132"/>
-      </a:accent2>
-      <a:accent3>
-        <a:srgbClr val="196B24"/>
-      </a:accent3>
-      <a:accent4>
-        <a:srgbClr val="0F9ED5"/>
-      </a:accent4>
-      <a:accent5>
-        <a:srgbClr val="A02B93"/>
-      </a:accent5>
-      <a:accent6>
-        <a:srgbClr val="4EA72E"/>
-      </a:accent6>
-      <a:hlink>
-        <a:srgbClr val="467886"/>
-      </a:hlink>
-      <a:folHlink>
-        <a:srgbClr val="96607D"/>
-      </a:folHlink>
-    </a:clrScheme>
-    <a:fontScheme name="Office">
-      <a:majorFont>
-        <a:latin typeface="Aptos Display" panose="02110004020202020204"/>
-        <a:ea typeface=""/>
-        <a:cs typeface=""/>
-        <a:font script="Jpan" typeface="游ゴシック Light"/>
-        <a:font script="Hang" typeface="맑은 고딕"/>
-        <a:font script="Hans" typeface="等线 Light"/>
-        <a:font script="Hant" typeface="新細明體"/>
-        <a:font script="Arab" typeface="Times New Roman"/>
-        <a:font script="Hebr" typeface="Times New Roman"/>
-        <a:font script="Thai" typeface="Angsana New"/>
-        <a:font script="Ethi" typeface="Nyala"/>
-        <a:font script="Beng" typeface="Vrinda"/>
-        <a:font script="Gujr" typeface="Shruti"/>
-        <a:font script="Khmr" typeface="MoolBoran"/>
-        <a:font script="Knda" typeface="Tunga"/>
-        <a:font script="Guru" typeface="Raavi"/>
-        <a:font script="Cans" typeface="Euphemia"/>
-        <a:font script="Cher" typeface="Plantagenet Cherokee"/>
-        <a:font script="Yiii" typeface="Microsoft Yi Baiti"/>
-        <a:font script="Tibt" typeface="Microsoft Himalaya"/>
-        <a:font script="Thaa" typeface="MV Boli"/>
-        <a:font script="Deva" typeface="Mangal"/>
-        <a:font script="Telu" typeface="Gautami"/>
-        <a:font script="Taml" typeface="Latha"/>
-        <a:font script="Syrc" typeface="Estrangelo Edessa"/>
-        <a:font script="Orya" typeface="Kalinga"/>
-        <a:font script="Mlym" typeface="Kartika"/>
-        <a:font script="Laoo" typeface="DokChampa"/>
-        <a:font script="Sinh" typeface="Iskoola Pota"/>
-        <a:font script="Mong" typeface="Mongolian Baiti"/>
-        <a:font script="Viet" typeface="Times New Roman"/>
-        <a:font script="Uigh" typeface="Microsoft Uighur"/>
-        <a:font script="Geor" typeface="Sylfaen"/>
-        <a:font script="Armn" typeface="Arial"/>
-        <a:font script="Bugi" typeface="Leelawadee UI"/>
-        <a:font script="Bopo" typeface="Microsoft JhengHei"/>
-        <a:font script="Java" typeface="Javanese Text"/>
-        <a:font script="Lisu" typeface="Segoe UI"/>
-        <a:font script="Mymr" typeface="Myanmar Text"/>
-        <a:font script="Nkoo" typeface="Ebrima"/>
-        <a:font script="Olck" typeface="Nirmala UI"/>
-        <a:font script="Osma" typeface="Ebrima"/>
-        <a:font script="Phag" typeface="Phagspa"/>
-        <a:font script="Syrn" typeface="Estrangelo Edessa"/>
-        <a:font script="Syrj" typeface="Estrangelo Edessa"/>
-        <a:font script="Syre" typeface="Estrangelo Edessa"/>
-        <a:font script="Sora" typeface="Nirmala UI"/>
-        <a:font script="Tale" typeface="Microsoft Tai Le"/>
-        <a:font script="Talu" typeface="Microsoft New Tai Lue"/>
-        <a:font script="Tfng" typeface="Ebrima"/>
-      </a:majorFont>
-      <a:minorFont>
-        <a:latin typeface="Aptos" panose="02110004020202020204"/>
-        <a:ea typeface=""/>
-        <a:cs typeface=""/>
-        <a:font script="Jpan" typeface="游ゴシック"/>
-        <a:font script="Hang" typeface="맑은 고딕"/>
-        <a:font script="Hans" typeface="等线"/>
-        <a:font script="Hant" typeface="新細明體"/>
-        <a:font script="Arab" typeface="Arial"/>
-        <a:font script="Hebr" typeface="Arial"/>
-        <a:font script="Thai" typeface="Cordia New"/>
-        <a:font script="Ethi" typeface="Nyala"/>
-        <a:font script="Beng" typeface="Vrinda"/>
-        <a:font script="Gujr" typeface="Shruti"/>
-        <a:font script="Khmr" typeface="DaunPenh"/>
-        <a:font script="Knda" typeface="Tunga"/>
-        <a:font script="Guru" typeface="Raavi"/>
-        <a:font script="Cans" typeface="Euphemia"/>
-        <a:font script="Cher" typeface="Plantagenet Cherokee"/>
-        <a:font script="Yiii" typeface="Microsoft Yi Baiti"/>
-        <a:font script="Tibt" typeface="Microsoft Himalaya"/>
-        <a:font script="Thaa" typeface="MV Boli"/>
-        <a:font script="Deva" typeface="Mangal"/>
-        <a:font script="Telu" typeface="Gautami"/>
-        <a:font script="Taml" typeface="Latha"/>
-        <a:font script="Syrc" typeface="Estrangelo Edessa"/>
-        <a:font script="Orya" typeface="Kalinga"/>
-        <a:font script="Mlym" typeface="Kartika"/>
-        <a:font script="Laoo" typeface="DokChampa"/>
-        <a:font script="Sinh" typeface="Iskoola Pota"/>
-        <a:font script="Mong" typeface="Mongolian Baiti"/>
-        <a:font script="Viet" typeface="Arial"/>
-        <a:font script="Uigh" typeface="Microsoft Uighur"/>
-        <a:font script="Geor" typeface="Sylfaen"/>
-        <a:font script="Armn" typeface="Arial"/>
-        <a:font script="Bugi" typeface="Leelawadee UI"/>
-        <a:font script="Bopo" typeface="Microsoft JhengHei"/>
-        <a:font script="Java" typeface="Javanese Text"/>
-        <a:font script="Lisu" typeface="Segoe UI"/>
-        <a:font script="Mymr" typeface="Myanmar Text"/>
-        <a:font script="Nkoo" typeface="Ebrima"/>
-        <a:font script="Olck" typeface="Nirmala UI"/>
-        <a:font script="Osma" typeface="Ebrima"/>
-        <a:font script="Phag" typeface="Phagspa"/>
-        <a:font script="Syrn" typeface="Estrangelo Edessa"/>
-        <a:font script="Syrj" typeface="Estrangelo Edessa"/>
-        <a:font script="Syre" typeface="Estrangelo Edessa"/>
-        <a:font script="Sora" typeface="Nirmala UI"/>
-        <a:font script="Tale" typeface="Microsoft Tai Le"/>
-        <a:font script="Talu" typeface="Microsoft New Tai Lue"/>
-        <a:font script="Tfng" typeface="Ebrima"/>
-      </a:minorFont>
-    </a:fontScheme>
-    <a:fmtScheme name="Office">
-      <a:fillStyleLst>
-        <a:solidFill>
-          <a:schemeClr val="phClr"/>
-        </a:solidFill>
-        <a:gradFill rotWithShape="1">
-          <a:gsLst>
-            <a:gs pos="0">
-              <a:schemeClr val="phClr">
-                <a:lumMod val="110000"/>
-                <a:satMod val="105000"/>
-                <a:tint val="67000"/>
-              </a:schemeClr>
-            </a:gs>
-            <a:gs pos="50000">
-              <a:schemeClr val="phClr">
-                <a:lumMod val="105000"/>
-                <a:satMod val="103000"/>
-                <a:tint val="73000"/>
-              </a:schemeClr>
-            </a:gs>
-            <a:gs pos="100000">
-              <a:schemeClr val="phClr">
-                <a:lumMod val="105000"/>
-                <a:satMod val="109000"/>
-                <a:tint val="81000"/>
-              </a:schemeClr>
-            </a:gs>
-          </a:gsLst>
-          <a:lin ang="5400000" scaled="0"/>
-        </a:gradFill>
-        <a:gradFill rotWithShape="1">
-          <a:gsLst>
-            <a:gs pos="0">
-              <a:schemeClr val="phClr">
-                <a:satMod val="103000"/>
-                <a:lumMod val="102000"/>
-                <a:tint val="94000"/>
-              </a:schemeClr>
-            </a:gs>
-            <a:gs pos="50000">
-              <a:schemeClr val="phClr">
-                <a:satMod val="110000"/>
-                <a:lumMod val="100000"/>
-                <a:shade val="100000"/>
-              </a:schemeClr>
-            </a:gs>
-            <a:gs pos="100000">
-              <a:schemeClr val="phClr">
-                <a:lumMod val="99000"/>
-                <a:satMod val="120000"/>
-                <a:shade val="78000"/>
-              </a:schemeClr>
-            </a:gs>
-          </a:gsLst>
-          <a:lin ang="5400000" scaled="0"/>
-        </a:gradFill>
-      </a:fillStyleLst>
-      <a:lnStyleLst>
-        <a:ln w="12700" cap="flat" cmpd="sng" algn="ctr">
-          <a:solidFill>
-            <a:schemeClr val="phClr"/>
-          </a:solidFill>
-          <a:prstDash val="solid"/>
-          <a:miter lim="800000"/>
-        </a:ln>
-        <a:ln w="19050" cap="flat" cmpd="sng" algn="ctr">
-          <a:solidFill>
-            <a:schemeClr val="phClr"/>
-          </a:solidFill>
-          <a:prstDash val="solid"/>
-          <a:miter lim="800000"/>
-        </a:ln>
-        <a:ln w="25400" cap="flat" cmpd="sng" algn="ctr">
-          <a:solidFill>
-            <a:schemeClr val="phClr"/>
-          </a:solidFill>
-          <a:prstDash val="solid"/>
-          <a:miter lim="800000"/>
-        </a:ln>
-      </a:lnStyleLst>
-      <a:effectStyleLst>
-        <a:effectStyle>
-          <a:effectLst/>
-        </a:effectStyle>
-        <a:effectStyle>
-          <a:effectLst/>
-        </a:effectStyle>
-        <a:effectStyle>
-          <a:effectLst>
-            <a:outerShdw blurRad="57150" dist="19050" dir="5400000" algn="ctr" rotWithShape="0">
-              <a:srgbClr val="000000">
-                <a:alpha val="63000"/>
-              </a:srgbClr>
-            </a:outerShdw>
-          </a:effectLst>
-        </a:effectStyle>
-      </a:effectStyleLst>
-      <a:bgFillStyleLst>
-        <a:solidFill>
-          <a:schemeClr val="phClr"/>
-        </a:solidFill>
-        <a:solidFill>
-          <a:schemeClr val="phClr">
-            <a:tint val="95000"/>
-            <a:satMod val="170000"/>
-          </a:schemeClr>
-        </a:solidFill>
-        <a:gradFill rotWithShape="1">
-          <a:gsLst>
-            <a:gs pos="0">
-              <a:schemeClr val="phClr">
-                <a:tint val="93000"/>
-                <a:satMod val="150000"/>
-                <a:shade val="98000"/>
-                <a:lumMod val="102000"/>
-              </a:schemeClr>
-            </a:gs>
-            <a:gs pos="50000">
-              <a:schemeClr val="phClr">
-                <a:tint val="98000"/>
-                <a:satMod val="130000"/>
-                <a:shade val="90000"/>
-                <a:lumMod val="103000"/>
-              </a:schemeClr>
-            </a:gs>
-            <a:gs pos="100000">
-              <a:schemeClr val="phClr">
-                <a:shade val="63000"/>
-                <a:satMod val="120000"/>
-              </a:schemeClr>
-            </a:gs>
-          </a:gsLst>
-          <a:lin ang="5400000" scaled="0"/>
-        </a:gradFill>
-      </a:bgFillStyleLst>
-    </a:fmtScheme>
-  </a:themeElements>
-  <a:objectDefaults>
-    <a:lnDef>
-      <a:spPr/>
-      <a:bodyPr/>
-      <a:lstStyle/>
-      <a:style>
-        <a:lnRef idx="2">
-          <a:schemeClr val="accent1"/>
-        </a:lnRef>
-        <a:fillRef idx="0">
-          <a:schemeClr val="accent1"/>
-        </a:fillRef>
-        <a:effectRef idx="1">
-          <a:schemeClr val="accent1"/>
-        </a:effectRef>
-        <a:fontRef idx="minor">
-          <a:schemeClr val="tx1"/>
-        </a:fontRef>
-      </a:style>
-    </a:lnDef>
-  </a:objectDefaults>
-  <a:extraClrSchemeLst/>
-  <a:extLst>
-    <a:ext uri="{05A4C25C-085E-4340-85A3-A5531E510DB2}">
-      <thm15:themeFamily xmlns:thm15="http://schemas.microsoft.com/office/thememl/2012/main" name="Office Theme" id="{2E142A2C-CD16-42D6-873A-C26D2A0506FA}" vid="{1BDDFF52-6CD6-40A5-AB3C-68EB2F1E4D0A}"/>
-    </a:ext>
-  </a:extLst>
-</a:theme>
-</file>
-
-<file path=docMetadata/LabelInfo.xml><?xml version="1.0" encoding="utf-8"?>
-<clbl:labelList xmlns:clbl="http://schemas.microsoft.com/office/2020/mipLabelMetadata">
-  <clbl:label id="{f42aa342-8706-4288-bd11-ebb85995028c}" enabled="1" method="Privileged" siteId="{72f988bf-86f1-41af-91ab-2d7cd011db47}" removed="0"/>
-</clbl:labelList>
 </file>
</xml_diff>

<commit_message>
Align repo to finalized architecture: add Formal (LEC) agent, declarative agents.yaml, drop Physical-Aware
- Render architecture from hand-tuned draw.io to PNG + SVG (docs/gen_diagram.py)
- Add Formal/Equivalence (LEC) agent end-to-end: sample soc_top_lec.rpt, parse_formal,
  LAYER_FORMAL routing in fix_router, formal_lec.md knowledge, enabled in agents.yaml
- Declarative agent registry (agents.yaml + agents/registry.py); Supervisor builds agents from config
- Remove Physical-Aware module + inert congestion.rpt; drop from UI, dashboard, deck, video, README, tests
- Refresh HTML dashboard (Formal layer, 4 modules) + screenshot; rebuild deck + video (1:59, same VO)
- Add MCP Tool-Control roadmap + input wrappers/grouping layer to diagram

Co-authored-by: Copilot <223556219+Copilot@users.noreply.github.com>
</commit_message>
<xml_diff>
--- a/docs/ClosureCopilot.pptx
+++ b/docs/ClosureCopilot.pptx
@@ -4017,7 +4017,7 @@
         <p:spPr>
           <a:xfrm>
             <a:off x="2148840" y="1170432"/>
-            <a:ext cx="7143469" cy="5257800"/>
+            <a:ext cx="7566160" cy="5257800"/>
           </a:xfrm>
           <a:prstGeom prst="rect">
             <a:avLst/>
@@ -4636,7 +4636,7 @@
                 </a:solidFill>
                 <a:latin typeface="Segoe UI"/>
               </a:rPr>
-              <a:t>Five modules, one dashboard</a:t>
+              <a:t>Five capabilities, one dashboard</a:t>
             </a:r>
           </a:p>
         </p:txBody>
@@ -5426,7 +5426,7 @@
                 </a:solidFill>
                 <a:latin typeface="Segoe UI"/>
               </a:rPr>
-              <a:t>Physical-Aware Feedback  —  </a:t>
+              <a:t>Formal Equivalence (LEC)  —  </a:t>
             </a:r>
           </a:p>
         </p:txBody>
@@ -5461,7 +5461,7 @@
                 </a:solidFill>
                 <a:latin typeface="Segoe UI"/>
               </a:rPr>
-              <a:t>Turns P&amp;R congestion into concrete RTL restructuring hints.</a:t>
+              <a:t>Routes LEC non-equivalence to a Formal-setup fix vs a genuine RTL bug.</a:t>
             </a:r>
           </a:p>
         </p:txBody>

</xml_diff>

<commit_message>
Fix video/deck to match latest diagram: 7 specialist agents (not 9), Formal routing
- Rewrite voiceover: 7 agents in 3 groups (Collaterals/PPA/Equivalence), formal LEC,
  drop 'nine specialists' + physical congestion; narration 1:57, video 1:59
- Slide/frame headers: '9 agents' -> '7 agents'; fix-layer line adds Formal
  (RTL | SDC | UPF | Synth | Formal)
- Rebuild deck (image MD5-matches user's architecture.png) + video

Co-authored-by: Copilot <223556219+Copilot@users.noreply.github.com>
</commit_message>
<xml_diff>
--- a/docs/ClosureCopilot.pptx
+++ b/docs/ClosureCopilot.pptx
@@ -3960,7 +3960,7 @@
                 </a:solidFill>
                 <a:latin typeface="Segoe UI"/>
               </a:rPr>
-              <a:t>One copilot · 9 agents · any backend report</a:t>
+              <a:t>One copilot · 7 agents · any backend report</a:t>
             </a:r>
           </a:p>
         </p:txBody>
@@ -4230,7 +4230,7 @@
                 </a:solidFill>
                 <a:latin typeface="Segoe UI"/>
               </a:rPr>
-              <a:t>For every issue, it decides WHERE the fix belongs — RTL · SDC · UPF · synthesis-setup.</a:t>
+              <a:t>For every issue, it decides WHERE the fix belongs — RTL · SDC · UPF · Synth · Formal.</a:t>
             </a:r>
           </a:p>
         </p:txBody>

</xml_diff>